<commit_message>
fix(report): replace ungrounded seed c2-035, drop claims the numbers do not support
</commit_message>
<xml_diff>
--- a/reports/Slide_BaoCao_DoAn.pptx
+++ b/reports/Slide_BaoCao_DoAn.pptx
@@ -3391,7 +3391,7 @@
                     <a:p>
                       <a:r>
                         <a:rPr sz="1300" b="1"/>
-                        <a:t>test</a:t>
+                        <a:t>Test synthetic</a:t>
                       </a:r>
                     </a:p>
                   </a:txBody>
@@ -3404,7 +3404,7 @@
                     <a:p>
                       <a:r>
                         <a:rPr sz="1300" b="1"/>
-                        <a:t>real</a:t>
+                        <a:t>Câu hỏi thật</a:t>
                       </a:r>
                     </a:p>
                   </a:txBody>
@@ -3419,7 +3419,7 @@
                     <a:p>
                       <a:r>
                         <a:rPr sz="1300"/>
-                        <a:t>oracle_top1</a:t>
+                        <a:t>Oracle Top-1</a:t>
                       </a:r>
                     </a:p>
                   </a:txBody>
@@ -3460,20 +3460,20 @@
                     <a:p>
                       <a:r>
                         <a:rPr sz="1300"/>
-                        <a:t>e2e_top1</a:t>
-                      </a:r>
-                    </a:p>
-                  </a:txBody>
-                  <a:tcPr/>
-                </a:tc>
-                <a:tc>
-                  <a:txBody>
-                    <a:bodyPr/>
-                    <a:lstStyle/>
-                    <a:p>
-                      <a:r>
-                        <a:rPr sz="1300"/>
-                        <a:t>74.8%</a:t>
+                        <a:t>End-to-end Top-1</a:t>
+                      </a:r>
+                    </a:p>
+                  </a:txBody>
+                  <a:tcPr/>
+                </a:tc>
+                <a:tc>
+                  <a:txBody>
+                    <a:bodyPr/>
+                    <a:lstStyle/>
+                    <a:p>
+                      <a:r>
+                        <a:rPr sz="1300"/>
+                        <a:t>75.2%</a:t>
                       </a:r>
                     </a:p>
                   </a:txBody>
@@ -3501,7 +3501,7 @@
                     <a:p>
                       <a:r>
                         <a:rPr sz="1300"/>
-                        <a:t>nofilter_top1</a:t>
+                        <a:t>No-filter Top-1</a:t>
                       </a:r>
                     </a:p>
                   </a:txBody>
@@ -3542,7 +3542,7 @@
                     <a:p>
                       <a:r>
                         <a:rPr sz="1300"/>
-                        <a:t>oracle_top3</a:t>
+                        <a:t>Oracle Top-3</a:t>
                       </a:r>
                     </a:p>
                   </a:txBody>
@@ -3583,20 +3583,20 @@
                     <a:p>
                       <a:r>
                         <a:rPr sz="1300"/>
-                        <a:t>e2e_top3</a:t>
-                      </a:r>
-                    </a:p>
-                  </a:txBody>
-                  <a:tcPr/>
-                </a:tc>
-                <a:tc>
-                  <a:txBody>
-                    <a:bodyPr/>
-                    <a:lstStyle/>
-                    <a:p>
-                      <a:r>
-                        <a:rPr sz="1300"/>
-                        <a:t>90.0%</a:t>
+                        <a:t>End-to-end Top-3</a:t>
+                      </a:r>
+                    </a:p>
+                  </a:txBody>
+                  <a:tcPr/>
+                </a:tc>
+                <a:tc>
+                  <a:txBody>
+                    <a:bodyPr/>
+                    <a:lstStyle/>
+                    <a:p>
+                      <a:r>
+                        <a:rPr sz="1300"/>
+                        <a:t>90.4%</a:t>
                       </a:r>
                     </a:p>
                   </a:txBody>
@@ -3624,7 +3624,7 @@
                     <a:p>
                       <a:r>
                         <a:rPr sz="1300"/>
-                        <a:t>nofilter_top3</a:t>
+                        <a:t>No-filter Top-3</a:t>
                       </a:r>
                     </a:p>
                   </a:txBody>
@@ -3665,7 +3665,7 @@
                     <a:p>
                       <a:r>
                         <a:rPr sz="1300"/>
-                        <a:t>oracle_top1_multi_article_classes</a:t>
+                        <a:t>Oracle Top-1 (lớp nhiều Điều)</a:t>
                       </a:r>
                     </a:p>
                   </a:txBody>
@@ -5588,7 +5588,7 @@
                     <a:p>
                       <a:r>
                         <a:rPr sz="1400"/>
-                        <a:t>86.3%</a:t>
+                        <a:t>86.0%</a:t>
                       </a:r>
                     </a:p>
                   </a:txBody>
@@ -5601,7 +5601,7 @@
                     <a:p>
                       <a:r>
                         <a:rPr sz="1400"/>
-                        <a:t>53.2%</a:t>
+                        <a:t>53.0%</a:t>
                       </a:r>
                     </a:p>
                   </a:txBody>
@@ -5629,7 +5629,7 @@
                     <a:p>
                       <a:r>
                         <a:rPr sz="1400"/>
-                        <a:t>83.3%</a:t>
+                        <a:t>83.6%</a:t>
                       </a:r>
                     </a:p>
                   </a:txBody>
@@ -5642,7 +5642,7 @@
                     <a:p>
                       <a:r>
                         <a:rPr sz="1400"/>
-                        <a:t>99.1%</a:t>
+                        <a:t>99.0%</a:t>
                       </a:r>
                     </a:p>
                   </a:txBody>
@@ -5709,7 +5709,7 @@
                     <a:p>
                       <a:r>
                         <a:rPr sz="1400"/>
-                        <a:t>82.6%</a:t>
+                        <a:t>82.8%</a:t>
                       </a:r>
                     </a:p>
                   </a:txBody>
@@ -5748,7 +5748,7 @@
                     <a:p>
                       <a:r>
                         <a:rPr sz="1400"/>
-                        <a:t>90.1%</a:t>
+                        <a:t>90.5%</a:t>
                       </a:r>
                     </a:p>
                   </a:txBody>
@@ -5789,7 +5789,7 @@
                     <a:p>
                       <a:r>
                         <a:rPr sz="1400"/>
-                        <a:t>81.2%</a:t>
+                        <a:t>81.7%</a:t>
                       </a:r>
                     </a:p>
                   </a:txBody>
@@ -5802,7 +5802,7 @@
                     <a:p>
                       <a:r>
                         <a:rPr sz="1400"/>
-                        <a:t>99.9%</a:t>
+                        <a:t>100.0%</a:t>
                       </a:r>
                     </a:p>
                   </a:txBody>
@@ -5815,7 +5815,7 @@
                     <a:p>
                       <a:r>
                         <a:rPr sz="1400"/>
-                        <a:t>82.8%</a:t>
+                        <a:t>80.2%</a:t>
                       </a:r>
                     </a:p>
                   </a:txBody>
@@ -5828,7 +5828,7 @@
                     <a:p>
                       <a:r>
                         <a:rPr sz="1400"/>
-                        <a:t>86.6%</a:t>
+                        <a:t>86.2%</a:t>
                       </a:r>
                     </a:p>
                   </a:txBody>
@@ -5841,7 +5841,7 @@
                     <a:p>
                       <a:r>
                         <a:rPr sz="1400"/>
-                        <a:t>43.7%</a:t>
+                        <a:t>47.0%</a:t>
                       </a:r>
                     </a:p>
                   </a:txBody>
@@ -6240,20 +6240,20 @@
                     <a:p>
                       <a:r>
                         <a:rPr sz="1300"/>
-                        <a:t>82.6% ± 6.5</a:t>
-                      </a:r>
-                    </a:p>
-                  </a:txBody>
-                  <a:tcPr/>
-                </a:tc>
-                <a:tc>
-                  <a:txBody>
-                    <a:bodyPr/>
-                    <a:lstStyle/>
-                    <a:p>
-                      <a:r>
-                        <a:rPr sz="1300"/>
-                        <a:t>90.1%</a:t>
+                        <a:t>82.8% ± 6.6</a:t>
+                      </a:r>
+                    </a:p>
+                  </a:txBody>
+                  <a:tcPr/>
+                </a:tc>
+                <a:tc>
+                  <a:txBody>
+                    <a:bodyPr/>
+                    <a:lstStyle/>
+                    <a:p>
+                      <a:r>
+                        <a:rPr sz="1300"/>
+                        <a:t>90.5%</a:t>
                       </a:r>
                     </a:p>
                   </a:txBody>
@@ -6294,7 +6294,7 @@
                     <a:p>
                       <a:r>
                         <a:rPr sz="1300"/>
-                        <a:t>82.1% ± 6.1</a:t>
+                        <a:t>82.2% ± 6.0</a:t>
                       </a:r>
                     </a:p>
                   </a:txBody>
@@ -6348,7 +6348,7 @@
                     <a:p>
                       <a:r>
                         <a:rPr sz="1300"/>
-                        <a:t>82.8% ± 5.5</a:t>
+                        <a:t>83.2% ± 5.3</a:t>
                       </a:r>
                     </a:p>
                   </a:txBody>
@@ -6402,20 +6402,20 @@
                     <a:p>
                       <a:r>
                         <a:rPr sz="1300"/>
-                        <a:t>81.5% ± 7.2</a:t>
-                      </a:r>
-                    </a:p>
-                  </a:txBody>
-                  <a:tcPr/>
-                </a:tc>
-                <a:tc>
-                  <a:txBody>
-                    <a:bodyPr/>
-                    <a:lstStyle/>
-                    <a:p>
-                      <a:r>
-                        <a:rPr sz="1300"/>
-                        <a:t>88.7%</a:t>
+                        <a:t>81.4% ± 7.0</a:t>
+                      </a:r>
+                    </a:p>
+                  </a:txBody>
+                  <a:tcPr/>
+                </a:tc>
+                <a:tc>
+                  <a:txBody>
+                    <a:bodyPr/>
+                    <a:lstStyle/>
+                    <a:p>
+                      <a:r>
+                        <a:rPr sz="1300"/>
+                        <a:t>89.2%</a:t>
                       </a:r>
                     </a:p>
                   </a:txBody>
@@ -6469,7 +6469,7 @@
                     <a:p>
                       <a:r>
                         <a:rPr sz="1300"/>
-                        <a:t>91.8%</a:t>
+                        <a:t>91.4%</a:t>
                       </a:r>
                     </a:p>
                   </a:txBody>
@@ -6689,7 +6689,7 @@
                   <a:srgbClr val="4A5568"/>
                 </a:solidFill>
               </a:rPr>
-              <a:t>– KHAI_BAO_DIEU_TRA -&gt; QUY_DINH_CHUNG: 12 lần</a:t>
+              <a:t>– KHAI_BAO_DIEU_TRA -&gt; QUY_DINH_CHUNG: 11 lần</a:t>
             </a:r>
           </a:p>
           <a:p>
@@ -6719,7 +6719,7 @@
                   <a:srgbClr val="1A202C"/>
                 </a:solidFill>
               </a:rPr>
-              <a:t>• Accuracy theo văn phong: complaint 87.0%, hr 91.3%, neutral 93.5%, short 91.3%, worker 89.1%</a:t>
+              <a:t>• Accuracy theo văn phong: complaint 87.0%, hr 91.3%, neutral 95.7%, short 91.3%, worker 89.1%</a:t>
             </a:r>
           </a:p>
           <a:p>

</xml_diff>

<commit_message>
docs: disclose LLM-generated data and labels, add team todo and review sheets
</commit_message>
<xml_diff>
--- a/reports/Slide_BaoCao_DoAn.pptx
+++ b/reports/Slide_BaoCao_DoAn.pptx
@@ -5013,7 +5013,7 @@
                   <a:srgbClr val="1A202C"/>
                 </a:solidFill>
               </a:rPr>
-              <a:t>• Synthetic có kiểm soát: 40 câu gốc/lớp viết từ nội dung Điều luật, 5 văn phong (trung tính, công nhân, HSE, khiếu nại, rút gọn)</a:t>
+              <a:t>• Synthetic do LLM (Claude) sinh từ nội dung Điều luật: 40 câu gốc/lớp, 5 văn phong; nhãn suy từ Điều, kiểm bằng validator</a:t>
             </a:r>
           </a:p>
           <a:p>
@@ -5073,7 +5073,7 @@
                   <a:srgbClr val="1A202C"/>
                 </a:solidFill>
               </a:rPr>
-              <a:t>• Test thật: 29 câu của người dân trên chinhsachonline.chinhphu.vn, nhãn theo Điều mà Bộ trả lời viện dẫn</a:t>
+              <a:t>• Test thật: 29 câu của người dân trên chinhsachonline.chinhphu.vn, nhãn (LLM gán, nhóm review dòng chưa chắc) theo Điều mà Bộ trả lời viện dẫn</a:t>
             </a:r>
           </a:p>
         </p:txBody>

</xml_diff>

<commit_message>
docs: rebuild report, slides and notebook on expanded real set
Report fills label agreement from reports/agreement.json when present; team-todo describes blind labeling.
</commit_message>
<xml_diff>
--- a/reports/Slide_BaoCao_DoAn.pptx
+++ b/reports/Slide_BaoCao_DoAn.pptx
@@ -3445,7 +3445,7 @@
                     <a:p>
                       <a:r>
                         <a:rPr sz="1300"/>
-                        <a:t>65.5%</a:t>
+                        <a:t>59.5%</a:t>
                       </a:r>
                     </a:p>
                   </a:txBody>
@@ -3486,7 +3486,7 @@
                     <a:p>
                       <a:r>
                         <a:rPr sz="1300"/>
-                        <a:t>55.2%</a:t>
+                        <a:t>50.0%</a:t>
                       </a:r>
                     </a:p>
                   </a:txBody>
@@ -3527,7 +3527,7 @@
                     <a:p>
                       <a:r>
                         <a:rPr sz="1300"/>
-                        <a:t>44.8%</a:t>
+                        <a:t>42.9%</a:t>
                       </a:r>
                     </a:p>
                   </a:txBody>
@@ -3568,7 +3568,7 @@
                     <a:p>
                       <a:r>
                         <a:rPr sz="1300"/>
-                        <a:t>96.5%</a:t>
+                        <a:t>92.9%</a:t>
                       </a:r>
                     </a:p>
                   </a:txBody>
@@ -3609,7 +3609,7 @@
                     <a:p>
                       <a:r>
                         <a:rPr sz="1300"/>
-                        <a:t>75.9%</a:t>
+                        <a:t>71.4%</a:t>
                       </a:r>
                     </a:p>
                   </a:txBody>
@@ -3650,7 +3650,7 @@
                     <a:p>
                       <a:r>
                         <a:rPr sz="1300"/>
-                        <a:t>79.3%</a:t>
+                        <a:t>73.8%</a:t>
                       </a:r>
                     </a:p>
                   </a:txBody>
@@ -3691,7 +3691,7 @@
                     <a:p>
                       <a:r>
                         <a:rPr sz="1300"/>
-                        <a:t>64.3%</a:t>
+                        <a:t>58.5%</a:t>
                       </a:r>
                     </a:p>
                   </a:txBody>
@@ -4975,7 +4975,7 @@
                   <a:srgbClr val="4A5568"/>
                 </a:solidFill>
               </a:rPr>
-              <a:t>1600 câu hỏi · 320 câu gốc × 5 văn phong · 29 câu hỏi thật</a:t>
+              <a:t>1600 câu hỏi · 320 câu gốc × 5 văn phong · 42 câu hỏi thật</a:t>
             </a:r>
           </a:p>
         </p:txBody>
@@ -5073,7 +5073,7 @@
                   <a:srgbClr val="1A202C"/>
                 </a:solidFill>
               </a:rPr>
-              <a:t>• Test thật: 29 câu của người dân trên chinhsachonline.chinhphu.vn, nhãn (LLM gán, nhóm review dòng chưa chắc) theo Điều mà Bộ trả lời viện dẫn</a:t>
+              <a:t>• Test thật: 42 câu của người dân trên chinhsachonline.chinhphu.vn, nhãn LLM gán theo Điều mà Bộ trả lời viện dẫn</a:t>
             </a:r>
           </a:p>
         </p:txBody>
@@ -5601,7 +5601,7 @@
                     <a:p>
                       <a:r>
                         <a:rPr sz="1400"/>
-                        <a:t>53.0%</a:t>
+                        <a:t>54.8%</a:t>
                       </a:r>
                     </a:p>
                   </a:txBody>
@@ -5681,7 +5681,7 @@
                     <a:p>
                       <a:r>
                         <a:rPr sz="1400"/>
-                        <a:t>58.9%</a:t>
+                        <a:t>60.3%</a:t>
                       </a:r>
                     </a:p>
                   </a:txBody>
@@ -5761,7 +5761,7 @@
                     <a:p>
                       <a:r>
                         <a:rPr sz="1400"/>
-                        <a:t>60.5%</a:t>
+                        <a:t>62.0%</a:t>
                       </a:r>
                     </a:p>
                   </a:txBody>
@@ -5841,7 +5841,7 @@
                     <a:p>
                       <a:r>
                         <a:rPr sz="1400"/>
-                        <a:t>47.0%</a:t>
+                        <a:t>51.2%</a:t>
                       </a:r>
                     </a:p>
                   </a:txBody>
@@ -6266,7 +6266,7 @@
                     <a:p>
                       <a:r>
                         <a:rPr sz="1300"/>
-                        <a:t>60.5%</a:t>
+                        <a:t>62.0%</a:t>
                       </a:r>
                     </a:p>
                   </a:txBody>
@@ -6320,7 +6320,7 @@
                     <a:p>
                       <a:r>
                         <a:rPr sz="1300"/>
-                        <a:t>57.1%</a:t>
+                        <a:t>58.6%</a:t>
                       </a:r>
                     </a:p>
                   </a:txBody>
@@ -6374,7 +6374,7 @@
                     <a:p>
                       <a:r>
                         <a:rPr sz="1300"/>
-                        <a:t>58.8%</a:t>
+                        <a:t>60.9%</a:t>
                       </a:r>
                     </a:p>
                   </a:txBody>
@@ -6428,7 +6428,7 @@
                     <a:p>
                       <a:r>
                         <a:rPr sz="1300"/>
-                        <a:t>58.8%</a:t>
+                        <a:t>62.0%</a:t>
                       </a:r>
                     </a:p>
                   </a:txBody>
@@ -6482,7 +6482,7 @@
                     <a:p>
                       <a:r>
                         <a:rPr sz="1300"/>
-                        <a:t>52.2%</a:t>
+                        <a:t>55.5%</a:t>
                       </a:r>
                     </a:p>
                   </a:txBody>
@@ -6734,7 +6734,7 @@
                   <a:srgbClr val="1A202C"/>
                 </a:solidFill>
               </a:rPr>
-              <a:t>• Câu hỏi thật dài ~127 âm tiết, nhiều bối cảnh và dẫn chiếu Nghị định → domain shift</a:t>
+              <a:t>• Câu hỏi thật dài ~106 âm tiết, nhiều bối cảnh và dẫn chiếu Nghị định → domain shift</a:t>
             </a:r>
           </a:p>
         </p:txBody>

</xml_diff>

<commit_message>
docs: update slide, member
</commit_message>
<xml_diff>
--- a/reports/Slide_BaoCao_DoAn.pptx
+++ b/reports/Slide_BaoCao_DoAn.pptx
@@ -5,20 +5,20 @@
     <p:sldMasterId id="2147483648" r:id="rId1"/>
   </p:sldMasterIdLst>
   <p:sldIdLst>
-    <p:sldId id="256" r:id="rId7"/>
-    <p:sldId id="257" r:id="rId8"/>
-    <p:sldId id="258" r:id="rId9"/>
-    <p:sldId id="259" r:id="rId10"/>
-    <p:sldId id="260" r:id="rId11"/>
-    <p:sldId id="261" r:id="rId12"/>
-    <p:sldId id="262" r:id="rId13"/>
-    <p:sldId id="263" r:id="rId14"/>
-    <p:sldId id="264" r:id="rId15"/>
-    <p:sldId id="265" r:id="rId16"/>
-    <p:sldId id="266" r:id="rId17"/>
-    <p:sldId id="267" r:id="rId18"/>
+    <p:sldId id="256" r:id="rId2"/>
+    <p:sldId id="257" r:id="rId3"/>
+    <p:sldId id="258" r:id="rId4"/>
+    <p:sldId id="259" r:id="rId5"/>
+    <p:sldId id="260" r:id="rId6"/>
+    <p:sldId id="261" r:id="rId7"/>
+    <p:sldId id="262" r:id="rId8"/>
+    <p:sldId id="263" r:id="rId9"/>
+    <p:sldId id="264" r:id="rId10"/>
+    <p:sldId id="265" r:id="rId11"/>
+    <p:sldId id="266" r:id="rId12"/>
+    <p:sldId id="267" r:id="rId13"/>
   </p:sldIdLst>
-  <p:sldSz cx="12191695" cy="6858000" type="screen4x3"/>
+  <p:sldSz cx="12192000" cy="6858000"/>
   <p:notesSz cx="6858000" cy="9144000"/>
   <p:defaultTextStyle>
     <a:defPPr>
@@ -115,7 +115,31 @@
       </a:defRPr>
     </a:lvl9pPr>
   </p:defaultTextStyle>
+  <p:extLst>
+    <p:ext uri="{EFAFB233-063F-42B5-8137-9DF3F51BA10A}">
+      <p15:sldGuideLst xmlns:p15="http://schemas.microsoft.com/office/powerpoint/2012/main">
+        <p15:guide id="1" orient="horz" pos="2160">
+          <p15:clr>
+            <a:srgbClr val="A4A3A4"/>
+          </p15:clr>
+        </p15:guide>
+        <p15:guide id="2" pos="2880">
+          <p15:clr>
+            <a:srgbClr val="A4A3A4"/>
+          </p15:clr>
+        </p15:guide>
+      </p15:sldGuideLst>
+    </p:ext>
+  </p:extLst>
 </p:presentation>
+</file>
+
+<file path=ppt/revisionInfo.xml><?xml version="1.0" encoding="utf-8"?>
+<p1510:revInfo xmlns:a="http://schemas.openxmlformats.org/drawingml/2006/main" xmlns:r="http://schemas.openxmlformats.org/officeDocument/2006/relationships" xmlns:p1510="http://schemas.microsoft.com/office/powerpoint/2015/10/main">
+  <p1510:revLst>
+    <p1510:client id="{00000000-0000-0000-0000-000000000000}" v="83" dt="2026-09-30T14:39:30.943"/>
+  </p1510:revLst>
+</p1510:revInfo>
 </file>
 
 <file path=ppt/slideLayouts/slideLayout1.xml><?xml version="1.0" encoding="utf-8"?>
@@ -156,10 +180,9 @@
           <a:lstStyle/>
           <a:p>
             <a:r>
-              <a:rPr lang="en-US" smtClean="0"/>
+              <a:rPr lang="en-US"/>
               <a:t>Click to edit Master title style</a:t>
             </a:r>
-            <a:endParaRPr lang="en-US"/>
           </a:p>
         </p:txBody>
       </p:sp>
@@ -275,10 +298,9 @@
           </a:lstStyle>
           <a:p>
             <a:r>
-              <a:rPr lang="en-US" smtClean="0"/>
+              <a:rPr lang="en-US"/>
               <a:t>Click to edit Master subtitle style</a:t>
             </a:r>
-            <a:endParaRPr lang="en-US"/>
           </a:p>
         </p:txBody>
       </p:sp>
@@ -299,7 +321,7 @@
           <a:p>
             <a:fld id="{5BCAD085-E8A6-8845-BD4E-CB4CCA059FC4}" type="datetimeFigureOut">
               <a:rPr lang="en-US" smtClean="0"/>
-              <a:t>1/27/13</a:t>
+              <a:t>9/30/2026</a:t>
             </a:fld>
             <a:endParaRPr lang="en-US"/>
           </a:p>
@@ -393,10 +415,9 @@
           <a:lstStyle/>
           <a:p>
             <a:r>
-              <a:rPr lang="en-US" smtClean="0"/>
+              <a:rPr lang="en-US"/>
               <a:t>Click to edit Master title style</a:t>
             </a:r>
-            <a:endParaRPr lang="en-US"/>
           </a:p>
         </p:txBody>
       </p:sp>
@@ -417,38 +438,37 @@
           <a:p>
             <a:pPr lvl="0"/>
             <a:r>
-              <a:rPr lang="en-US" smtClean="0"/>
+              <a:rPr lang="en-US"/>
               <a:t>Click to edit Master text styles</a:t>
             </a:r>
           </a:p>
           <a:p>
             <a:pPr lvl="1"/>
             <a:r>
-              <a:rPr lang="en-US" smtClean="0"/>
+              <a:rPr lang="en-US"/>
               <a:t>Second level</a:t>
             </a:r>
           </a:p>
           <a:p>
             <a:pPr lvl="2"/>
             <a:r>
-              <a:rPr lang="en-US" smtClean="0"/>
+              <a:rPr lang="en-US"/>
               <a:t>Third level</a:t>
             </a:r>
           </a:p>
           <a:p>
             <a:pPr lvl="3"/>
             <a:r>
-              <a:rPr lang="en-US" smtClean="0"/>
+              <a:rPr lang="en-US"/>
               <a:t>Fourth level</a:t>
             </a:r>
           </a:p>
           <a:p>
             <a:pPr lvl="4"/>
             <a:r>
-              <a:rPr lang="en-US" smtClean="0"/>
+              <a:rPr lang="en-US"/>
               <a:t>Fifth level</a:t>
             </a:r>
-            <a:endParaRPr lang="en-US"/>
           </a:p>
         </p:txBody>
       </p:sp>
@@ -469,7 +489,7 @@
           <a:p>
             <a:fld id="{5BCAD085-E8A6-8845-BD4E-CB4CCA059FC4}" type="datetimeFigureOut">
               <a:rPr lang="en-US" smtClean="0"/>
-              <a:t>1/27/13</a:t>
+              <a:t>9/30/2026</a:t>
             </a:fld>
             <a:endParaRPr lang="en-US"/>
           </a:p>
@@ -568,10 +588,9 @@
           <a:lstStyle/>
           <a:p>
             <a:r>
-              <a:rPr lang="en-US" smtClean="0"/>
+              <a:rPr lang="en-US"/>
               <a:t>Click to edit Master title style</a:t>
             </a:r>
-            <a:endParaRPr lang="en-US"/>
           </a:p>
         </p:txBody>
       </p:sp>
@@ -597,38 +616,37 @@
           <a:p>
             <a:pPr lvl="0"/>
             <a:r>
-              <a:rPr lang="en-US" smtClean="0"/>
+              <a:rPr lang="en-US"/>
               <a:t>Click to edit Master text styles</a:t>
             </a:r>
           </a:p>
           <a:p>
             <a:pPr lvl="1"/>
             <a:r>
-              <a:rPr lang="en-US" smtClean="0"/>
+              <a:rPr lang="en-US"/>
               <a:t>Second level</a:t>
             </a:r>
           </a:p>
           <a:p>
             <a:pPr lvl="2"/>
             <a:r>
-              <a:rPr lang="en-US" smtClean="0"/>
+              <a:rPr lang="en-US"/>
               <a:t>Third level</a:t>
             </a:r>
           </a:p>
           <a:p>
             <a:pPr lvl="3"/>
             <a:r>
-              <a:rPr lang="en-US" smtClean="0"/>
+              <a:rPr lang="en-US"/>
               <a:t>Fourth level</a:t>
             </a:r>
           </a:p>
           <a:p>
             <a:pPr lvl="4"/>
             <a:r>
-              <a:rPr lang="en-US" smtClean="0"/>
+              <a:rPr lang="en-US"/>
               <a:t>Fifth level</a:t>
             </a:r>
-            <a:endParaRPr lang="en-US"/>
           </a:p>
         </p:txBody>
       </p:sp>
@@ -649,7 +667,7 @@
           <a:p>
             <a:fld id="{5BCAD085-E8A6-8845-BD4E-CB4CCA059FC4}" type="datetimeFigureOut">
               <a:rPr lang="en-US" smtClean="0"/>
-              <a:t>1/27/13</a:t>
+              <a:t>9/30/2026</a:t>
             </a:fld>
             <a:endParaRPr lang="en-US"/>
           </a:p>
@@ -743,10 +761,9 @@
           <a:lstStyle/>
           <a:p>
             <a:r>
-              <a:rPr lang="en-US" smtClean="0"/>
+              <a:rPr lang="en-US"/>
               <a:t>Click to edit Master title style</a:t>
             </a:r>
-            <a:endParaRPr lang="en-US"/>
           </a:p>
         </p:txBody>
       </p:sp>
@@ -767,38 +784,37 @@
           <a:p>
             <a:pPr lvl="0"/>
             <a:r>
-              <a:rPr lang="en-US" smtClean="0"/>
+              <a:rPr lang="en-US"/>
               <a:t>Click to edit Master text styles</a:t>
             </a:r>
           </a:p>
           <a:p>
             <a:pPr lvl="1"/>
             <a:r>
-              <a:rPr lang="en-US" smtClean="0"/>
+              <a:rPr lang="en-US"/>
               <a:t>Second level</a:t>
             </a:r>
           </a:p>
           <a:p>
             <a:pPr lvl="2"/>
             <a:r>
-              <a:rPr lang="en-US" smtClean="0"/>
+              <a:rPr lang="en-US"/>
               <a:t>Third level</a:t>
             </a:r>
           </a:p>
           <a:p>
             <a:pPr lvl="3"/>
             <a:r>
-              <a:rPr lang="en-US" smtClean="0"/>
+              <a:rPr lang="en-US"/>
               <a:t>Fourth level</a:t>
             </a:r>
           </a:p>
           <a:p>
             <a:pPr lvl="4"/>
             <a:r>
-              <a:rPr lang="en-US" smtClean="0"/>
+              <a:rPr lang="en-US"/>
               <a:t>Fifth level</a:t>
             </a:r>
-            <a:endParaRPr lang="en-US"/>
           </a:p>
         </p:txBody>
       </p:sp>
@@ -819,7 +835,7 @@
           <a:p>
             <a:fld id="{5BCAD085-E8A6-8845-BD4E-CB4CCA059FC4}" type="datetimeFigureOut">
               <a:rPr lang="en-US" smtClean="0"/>
-              <a:t>1/27/13</a:t>
+              <a:t>9/30/2026</a:t>
             </a:fld>
             <a:endParaRPr lang="en-US"/>
           </a:p>
@@ -922,10 +938,9 @@
           </a:lstStyle>
           <a:p>
             <a:r>
-              <a:rPr lang="en-US" smtClean="0"/>
+              <a:rPr lang="en-US"/>
               <a:t>Click to edit Master title style</a:t>
             </a:r>
-            <a:endParaRPr lang="en-US"/>
           </a:p>
         </p:txBody>
       </p:sp>
@@ -1042,7 +1057,7 @@
           <a:p>
             <a:pPr lvl="0"/>
             <a:r>
-              <a:rPr lang="en-US" smtClean="0"/>
+              <a:rPr lang="en-US"/>
               <a:t>Click to edit Master text styles</a:t>
             </a:r>
           </a:p>
@@ -1065,7 +1080,7 @@
           <a:p>
             <a:fld id="{5BCAD085-E8A6-8845-BD4E-CB4CCA059FC4}" type="datetimeFigureOut">
               <a:rPr lang="en-US" smtClean="0"/>
-              <a:t>1/27/13</a:t>
+              <a:t>9/30/2026</a:t>
             </a:fld>
             <a:endParaRPr lang="en-US"/>
           </a:p>
@@ -1159,10 +1174,9 @@
           <a:lstStyle/>
           <a:p>
             <a:r>
-              <a:rPr lang="en-US" smtClean="0"/>
+              <a:rPr lang="en-US"/>
               <a:t>Click to edit Master title style</a:t>
             </a:r>
-            <a:endParaRPr lang="en-US"/>
           </a:p>
         </p:txBody>
       </p:sp>
@@ -1216,38 +1230,37 @@
           <a:p>
             <a:pPr lvl="0"/>
             <a:r>
-              <a:rPr lang="en-US" smtClean="0"/>
+              <a:rPr lang="en-US"/>
               <a:t>Click to edit Master text styles</a:t>
             </a:r>
           </a:p>
           <a:p>
             <a:pPr lvl="1"/>
             <a:r>
-              <a:rPr lang="en-US" smtClean="0"/>
+              <a:rPr lang="en-US"/>
               <a:t>Second level</a:t>
             </a:r>
           </a:p>
           <a:p>
             <a:pPr lvl="2"/>
             <a:r>
-              <a:rPr lang="en-US" smtClean="0"/>
+              <a:rPr lang="en-US"/>
               <a:t>Third level</a:t>
             </a:r>
           </a:p>
           <a:p>
             <a:pPr lvl="3"/>
             <a:r>
-              <a:rPr lang="en-US" smtClean="0"/>
+              <a:rPr lang="en-US"/>
               <a:t>Fourth level</a:t>
             </a:r>
           </a:p>
           <a:p>
             <a:pPr lvl="4"/>
             <a:r>
-              <a:rPr lang="en-US" smtClean="0"/>
+              <a:rPr lang="en-US"/>
               <a:t>Fifth level</a:t>
             </a:r>
-            <a:endParaRPr lang="en-US"/>
           </a:p>
         </p:txBody>
       </p:sp>
@@ -1301,38 +1314,37 @@
           <a:p>
             <a:pPr lvl="0"/>
             <a:r>
-              <a:rPr lang="en-US" smtClean="0"/>
+              <a:rPr lang="en-US"/>
               <a:t>Click to edit Master text styles</a:t>
             </a:r>
           </a:p>
           <a:p>
             <a:pPr lvl="1"/>
             <a:r>
-              <a:rPr lang="en-US" smtClean="0"/>
+              <a:rPr lang="en-US"/>
               <a:t>Second level</a:t>
             </a:r>
           </a:p>
           <a:p>
             <a:pPr lvl="2"/>
             <a:r>
-              <a:rPr lang="en-US" smtClean="0"/>
+              <a:rPr lang="en-US"/>
               <a:t>Third level</a:t>
             </a:r>
           </a:p>
           <a:p>
             <a:pPr lvl="3"/>
             <a:r>
-              <a:rPr lang="en-US" smtClean="0"/>
+              <a:rPr lang="en-US"/>
               <a:t>Fourth level</a:t>
             </a:r>
           </a:p>
           <a:p>
             <a:pPr lvl="4"/>
             <a:r>
-              <a:rPr lang="en-US" smtClean="0"/>
+              <a:rPr lang="en-US"/>
               <a:t>Fifth level</a:t>
             </a:r>
-            <a:endParaRPr lang="en-US"/>
           </a:p>
         </p:txBody>
       </p:sp>
@@ -1353,7 +1365,7 @@
           <a:p>
             <a:fld id="{5BCAD085-E8A6-8845-BD4E-CB4CCA059FC4}" type="datetimeFigureOut">
               <a:rPr lang="en-US" smtClean="0"/>
-              <a:t>1/27/13</a:t>
+              <a:t>9/30/2026</a:t>
             </a:fld>
             <a:endParaRPr lang="en-US"/>
           </a:p>
@@ -1451,10 +1463,9 @@
           </a:lstStyle>
           <a:p>
             <a:r>
-              <a:rPr lang="en-US" smtClean="0"/>
+              <a:rPr lang="en-US"/>
               <a:t>Click to edit Master title style</a:t>
             </a:r>
-            <a:endParaRPr lang="en-US"/>
           </a:p>
         </p:txBody>
       </p:sp>
@@ -1517,7 +1528,7 @@
           <a:p>
             <a:pPr lvl="0"/>
             <a:r>
-              <a:rPr lang="en-US" smtClean="0"/>
+              <a:rPr lang="en-US"/>
               <a:t>Click to edit Master text styles</a:t>
             </a:r>
           </a:p>
@@ -1573,38 +1584,37 @@
           <a:p>
             <a:pPr lvl="0"/>
             <a:r>
-              <a:rPr lang="en-US" smtClean="0"/>
+              <a:rPr lang="en-US"/>
               <a:t>Click to edit Master text styles</a:t>
             </a:r>
           </a:p>
           <a:p>
             <a:pPr lvl="1"/>
             <a:r>
-              <a:rPr lang="en-US" smtClean="0"/>
+              <a:rPr lang="en-US"/>
               <a:t>Second level</a:t>
             </a:r>
           </a:p>
           <a:p>
             <a:pPr lvl="2"/>
             <a:r>
-              <a:rPr lang="en-US" smtClean="0"/>
+              <a:rPr lang="en-US"/>
               <a:t>Third level</a:t>
             </a:r>
           </a:p>
           <a:p>
             <a:pPr lvl="3"/>
             <a:r>
-              <a:rPr lang="en-US" smtClean="0"/>
+              <a:rPr lang="en-US"/>
               <a:t>Fourth level</a:t>
             </a:r>
           </a:p>
           <a:p>
             <a:pPr lvl="4"/>
             <a:r>
-              <a:rPr lang="en-US" smtClean="0"/>
+              <a:rPr lang="en-US"/>
               <a:t>Fifth level</a:t>
             </a:r>
-            <a:endParaRPr lang="en-US"/>
           </a:p>
         </p:txBody>
       </p:sp>
@@ -1667,7 +1677,7 @@
           <a:p>
             <a:pPr lvl="0"/>
             <a:r>
-              <a:rPr lang="en-US" smtClean="0"/>
+              <a:rPr lang="en-US"/>
               <a:t>Click to edit Master text styles</a:t>
             </a:r>
           </a:p>
@@ -1723,38 +1733,37 @@
           <a:p>
             <a:pPr lvl="0"/>
             <a:r>
-              <a:rPr lang="en-US" smtClean="0"/>
+              <a:rPr lang="en-US"/>
               <a:t>Click to edit Master text styles</a:t>
             </a:r>
           </a:p>
           <a:p>
             <a:pPr lvl="1"/>
             <a:r>
-              <a:rPr lang="en-US" smtClean="0"/>
+              <a:rPr lang="en-US"/>
               <a:t>Second level</a:t>
             </a:r>
           </a:p>
           <a:p>
             <a:pPr lvl="2"/>
             <a:r>
-              <a:rPr lang="en-US" smtClean="0"/>
+              <a:rPr lang="en-US"/>
               <a:t>Third level</a:t>
             </a:r>
           </a:p>
           <a:p>
             <a:pPr lvl="3"/>
             <a:r>
-              <a:rPr lang="en-US" smtClean="0"/>
+              <a:rPr lang="en-US"/>
               <a:t>Fourth level</a:t>
             </a:r>
           </a:p>
           <a:p>
             <a:pPr lvl="4"/>
             <a:r>
-              <a:rPr lang="en-US" smtClean="0"/>
+              <a:rPr lang="en-US"/>
               <a:t>Fifth level</a:t>
             </a:r>
-            <a:endParaRPr lang="en-US"/>
           </a:p>
         </p:txBody>
       </p:sp>
@@ -1775,7 +1784,7 @@
           <a:p>
             <a:fld id="{5BCAD085-E8A6-8845-BD4E-CB4CCA059FC4}" type="datetimeFigureOut">
               <a:rPr lang="en-US" smtClean="0"/>
-              <a:t>1/27/13</a:t>
+              <a:t>9/30/2026</a:t>
             </a:fld>
             <a:endParaRPr lang="en-US"/>
           </a:p>
@@ -1869,10 +1878,9 @@
           <a:lstStyle/>
           <a:p>
             <a:r>
-              <a:rPr lang="en-US" smtClean="0"/>
+              <a:rPr lang="en-US"/>
               <a:t>Click to edit Master title style</a:t>
             </a:r>
-            <a:endParaRPr lang="en-US"/>
           </a:p>
         </p:txBody>
       </p:sp>
@@ -1893,7 +1901,7 @@
           <a:p>
             <a:fld id="{5BCAD085-E8A6-8845-BD4E-CB4CCA059FC4}" type="datetimeFigureOut">
               <a:rPr lang="en-US" smtClean="0"/>
-              <a:t>1/27/13</a:t>
+              <a:t>9/30/2026</a:t>
             </a:fld>
             <a:endParaRPr lang="en-US"/>
           </a:p>
@@ -1988,7 +1996,7 @@
           <a:p>
             <a:fld id="{5BCAD085-E8A6-8845-BD4E-CB4CCA059FC4}" type="datetimeFigureOut">
               <a:rPr lang="en-US" smtClean="0"/>
-              <a:t>1/27/13</a:t>
+              <a:t>9/30/2026</a:t>
             </a:fld>
             <a:endParaRPr lang="en-US"/>
           </a:p>
@@ -2091,10 +2099,9 @@
           </a:lstStyle>
           <a:p>
             <a:r>
-              <a:rPr lang="en-US" smtClean="0"/>
+              <a:rPr lang="en-US"/>
               <a:t>Click to edit Master title style</a:t>
             </a:r>
-            <a:endParaRPr lang="en-US"/>
           </a:p>
         </p:txBody>
       </p:sp>
@@ -2148,38 +2155,37 @@
           <a:p>
             <a:pPr lvl="0"/>
             <a:r>
-              <a:rPr lang="en-US" smtClean="0"/>
+              <a:rPr lang="en-US"/>
               <a:t>Click to edit Master text styles</a:t>
             </a:r>
           </a:p>
           <a:p>
             <a:pPr lvl="1"/>
             <a:r>
-              <a:rPr lang="en-US" smtClean="0"/>
+              <a:rPr lang="en-US"/>
               <a:t>Second level</a:t>
             </a:r>
           </a:p>
           <a:p>
             <a:pPr lvl="2"/>
             <a:r>
-              <a:rPr lang="en-US" smtClean="0"/>
+              <a:rPr lang="en-US"/>
               <a:t>Third level</a:t>
             </a:r>
           </a:p>
           <a:p>
             <a:pPr lvl="3"/>
             <a:r>
-              <a:rPr lang="en-US" smtClean="0"/>
+              <a:rPr lang="en-US"/>
               <a:t>Fourth level</a:t>
             </a:r>
           </a:p>
           <a:p>
             <a:pPr lvl="4"/>
             <a:r>
-              <a:rPr lang="en-US" smtClean="0"/>
+              <a:rPr lang="en-US"/>
               <a:t>Fifth level</a:t>
             </a:r>
-            <a:endParaRPr lang="en-US"/>
           </a:p>
         </p:txBody>
       </p:sp>
@@ -2242,7 +2248,7 @@
           <a:p>
             <a:pPr lvl="0"/>
             <a:r>
-              <a:rPr lang="en-US" smtClean="0"/>
+              <a:rPr lang="en-US"/>
               <a:t>Click to edit Master text styles</a:t>
             </a:r>
           </a:p>
@@ -2265,7 +2271,7 @@
           <a:p>
             <a:fld id="{5BCAD085-E8A6-8845-BD4E-CB4CCA059FC4}" type="datetimeFigureOut">
               <a:rPr lang="en-US" smtClean="0"/>
-              <a:t>1/27/13</a:t>
+              <a:t>9/30/2026</a:t>
             </a:fld>
             <a:endParaRPr lang="en-US"/>
           </a:p>
@@ -2368,10 +2374,9 @@
           </a:lstStyle>
           <a:p>
             <a:r>
-              <a:rPr lang="en-US" smtClean="0"/>
+              <a:rPr lang="en-US"/>
               <a:t>Click to edit Master title style</a:t>
             </a:r>
-            <a:endParaRPr lang="en-US"/>
           </a:p>
         </p:txBody>
       </p:sp>
@@ -2495,7 +2500,7 @@
           <a:p>
             <a:pPr lvl="0"/>
             <a:r>
-              <a:rPr lang="en-US" smtClean="0"/>
+              <a:rPr lang="en-US"/>
               <a:t>Click to edit Master text styles</a:t>
             </a:r>
           </a:p>
@@ -2518,7 +2523,7 @@
           <a:p>
             <a:fld id="{5BCAD085-E8A6-8845-BD4E-CB4CCA059FC4}" type="datetimeFigureOut">
               <a:rPr lang="en-US" smtClean="0"/>
-              <a:t>1/27/13</a:t>
+              <a:t>9/30/2026</a:t>
             </a:fld>
             <a:endParaRPr lang="en-US"/>
           </a:p>
@@ -2627,10 +2632,9 @@
           <a:lstStyle/>
           <a:p>
             <a:r>
-              <a:rPr lang="en-US" smtClean="0"/>
+              <a:rPr lang="en-US"/>
               <a:t>Click to edit Master title style</a:t>
             </a:r>
-            <a:endParaRPr lang="en-US"/>
           </a:p>
         </p:txBody>
       </p:sp>
@@ -2661,38 +2665,37 @@
           <a:p>
             <a:pPr lvl="0"/>
             <a:r>
-              <a:rPr lang="en-US" smtClean="0"/>
+              <a:rPr lang="en-US"/>
               <a:t>Click to edit Master text styles</a:t>
             </a:r>
           </a:p>
           <a:p>
             <a:pPr lvl="1"/>
             <a:r>
-              <a:rPr lang="en-US" smtClean="0"/>
+              <a:rPr lang="en-US"/>
               <a:t>Second level</a:t>
             </a:r>
           </a:p>
           <a:p>
             <a:pPr lvl="2"/>
             <a:r>
-              <a:rPr lang="en-US" smtClean="0"/>
+              <a:rPr lang="en-US"/>
               <a:t>Third level</a:t>
             </a:r>
           </a:p>
           <a:p>
             <a:pPr lvl="3"/>
             <a:r>
-              <a:rPr lang="en-US" smtClean="0"/>
+              <a:rPr lang="en-US"/>
               <a:t>Fourth level</a:t>
             </a:r>
           </a:p>
           <a:p>
             <a:pPr lvl="4"/>
             <a:r>
-              <a:rPr lang="en-US" smtClean="0"/>
+              <a:rPr lang="en-US"/>
               <a:t>Fifth level</a:t>
             </a:r>
-            <a:endParaRPr lang="en-US"/>
           </a:p>
         </p:txBody>
       </p:sp>
@@ -2731,7 +2734,7 @@
           <a:p>
             <a:fld id="{5BCAD085-E8A6-8845-BD4E-CB4CCA059FC4}" type="datetimeFigureOut">
               <a:rPr lang="en-US" smtClean="0"/>
-              <a:t>1/27/13</a:t>
+              <a:t>9/30/2026</a:t>
             </a:fld>
             <a:endParaRPr lang="en-US"/>
           </a:p>
@@ -3090,7 +3093,7 @@
 </file>
 
 <file path=ppt/slides/slide1.xml><?xml version="1.0" encoding="utf-8"?>
-<p:sld xmlns:a="http://schemas.openxmlformats.org/drawingml/2006/main" xmlns:p="http://schemas.openxmlformats.org/presentationml/2006/main" xmlns:r="http://schemas.openxmlformats.org/officeDocument/2006/relationships">
+<p:sld xmlns:a="http://schemas.openxmlformats.org/drawingml/2006/main" xmlns:r="http://schemas.openxmlformats.org/officeDocument/2006/relationships" xmlns:p="http://schemas.openxmlformats.org/presentationml/2006/main">
   <p:cSld>
     <p:spTree>
       <p:nvGrpSpPr>
@@ -3098,7 +3101,14 @@
         <p:cNvGrpSpPr/>
         <p:nvPr/>
       </p:nvGrpSpPr>
-      <p:grpSpPr/>
+      <p:grpSpPr>
+        <a:xfrm>
+          <a:off x="0" y="0"/>
+          <a:ext cx="0" cy="0"/>
+          <a:chOff x="0" y="0"/>
+          <a:chExt cx="0" cy="0"/>
+        </a:xfrm>
+      </p:grpSpPr>
       <p:sp>
         <p:nvSpPr>
           <p:cNvPr id="2" name="Rectangle 1"/>
@@ -3139,6 +3149,7 @@
           <a:lstStyle/>
           <a:p>
             <a:pPr algn="ctr"/>
+            <a:endParaRPr/>
           </a:p>
         </p:txBody>
       </p:sp>
@@ -3151,7 +3162,7 @@
         <p:spPr>
           <a:xfrm>
             <a:off x="548640" y="320040"/>
-            <a:ext cx="10972800" cy="822960"/>
+            <a:ext cx="9489970" cy="1292662"/>
           </a:xfrm>
           <a:prstGeom prst="rect">
             <a:avLst/>
@@ -3159,29 +3170,285 @@
           <a:noFill/>
         </p:spPr>
         <p:txBody>
-          <a:bodyPr wrap="none">
+          <a:bodyPr wrap="none" lIns="91440" tIns="45720" rIns="91440" bIns="45720" anchor="t">
             <a:spAutoFit/>
           </a:bodyPr>
           <a:lstStyle/>
           <a:p>
             <a:r>
-              <a:rPr sz="3000" b="1">
+              <a:rPr sz="3000" b="1" dirty="0">
                 <a:solidFill>
                   <a:srgbClr val="1A365D"/>
                 </a:solidFill>
               </a:rPr>
-              <a:t>Tra cứu Luật An toàn, vệ sinh lao động bằng NLP tiếng Việt</a:t>
-            </a:r>
-          </a:p>
-          <a:p>
-            <a:r>
-              <a:rPr sz="1500">
+              <a:t>Tra </a:t>
+            </a:r>
+            <a:r>
+              <a:rPr sz="3000" b="1" dirty="0" err="1">
+                <a:solidFill>
+                  <a:srgbClr val="1A365D"/>
+                </a:solidFill>
+              </a:rPr>
+              <a:t>cứu</a:t>
+            </a:r>
+            <a:r>
+              <a:rPr sz="3000" b="1" dirty="0">
+                <a:solidFill>
+                  <a:srgbClr val="1A365D"/>
+                </a:solidFill>
+              </a:rPr>
+              <a:t> </a:t>
+            </a:r>
+            <a:r>
+              <a:rPr sz="3000" b="1" dirty="0" err="1">
+                <a:solidFill>
+                  <a:srgbClr val="1A365D"/>
+                </a:solidFill>
+              </a:rPr>
+              <a:t>Luật</a:t>
+            </a:r>
+            <a:r>
+              <a:rPr sz="3000" b="1" dirty="0">
+                <a:solidFill>
+                  <a:srgbClr val="1A365D"/>
+                </a:solidFill>
+              </a:rPr>
+              <a:t> An </a:t>
+            </a:r>
+            <a:r>
+              <a:rPr sz="3000" b="1" dirty="0" err="1">
+                <a:solidFill>
+                  <a:srgbClr val="1A365D"/>
+                </a:solidFill>
+              </a:rPr>
+              <a:t>toàn</a:t>
+            </a:r>
+            <a:r>
+              <a:rPr sz="3000" b="1" dirty="0">
+                <a:solidFill>
+                  <a:srgbClr val="1A365D"/>
+                </a:solidFill>
+              </a:rPr>
+              <a:t>, </a:t>
+            </a:r>
+            <a:r>
+              <a:rPr sz="3000" b="1" dirty="0" err="1">
+                <a:solidFill>
+                  <a:srgbClr val="1A365D"/>
+                </a:solidFill>
+              </a:rPr>
+              <a:t>vệ</a:t>
+            </a:r>
+            <a:r>
+              <a:rPr sz="3000" b="1" dirty="0">
+                <a:solidFill>
+                  <a:srgbClr val="1A365D"/>
+                </a:solidFill>
+              </a:rPr>
+              <a:t> </a:t>
+            </a:r>
+            <a:r>
+              <a:rPr sz="3000" b="1" dirty="0" err="1">
+                <a:solidFill>
+                  <a:srgbClr val="1A365D"/>
+                </a:solidFill>
+              </a:rPr>
+              <a:t>sinh</a:t>
+            </a:r>
+            <a:r>
+              <a:rPr sz="3000" b="1" dirty="0">
+                <a:solidFill>
+                  <a:srgbClr val="1A365D"/>
+                </a:solidFill>
+              </a:rPr>
+              <a:t> </a:t>
+            </a:r>
+            <a:r>
+              <a:rPr sz="3000" b="1" dirty="0" err="1">
+                <a:solidFill>
+                  <a:srgbClr val="1A365D"/>
+                </a:solidFill>
+              </a:rPr>
+              <a:t>lao</a:t>
+            </a:r>
+            <a:r>
+              <a:rPr sz="3000" b="1" dirty="0">
+                <a:solidFill>
+                  <a:srgbClr val="1A365D"/>
+                </a:solidFill>
+              </a:rPr>
+              <a:t> </a:t>
+            </a:r>
+            <a:r>
+              <a:rPr sz="3000" b="1" dirty="0" err="1">
+                <a:solidFill>
+                  <a:srgbClr val="1A365D"/>
+                </a:solidFill>
+              </a:rPr>
+              <a:t>động</a:t>
+            </a:r>
+            <a:r>
+              <a:rPr sz="3000" b="1" dirty="0">
+                <a:solidFill>
+                  <a:srgbClr val="1A365D"/>
+                </a:solidFill>
+              </a:rPr>
+              <a:t> </a:t>
+            </a:r>
+            <a:r>
+              <a:rPr sz="3000" b="1" dirty="0" err="1">
+                <a:solidFill>
+                  <a:srgbClr val="1A365D"/>
+                </a:solidFill>
+              </a:rPr>
+              <a:t>bằng</a:t>
+            </a:r>
+            <a:r>
+              <a:rPr sz="3000" b="1" dirty="0">
+                <a:solidFill>
+                  <a:srgbClr val="1A365D"/>
+                </a:solidFill>
+              </a:rPr>
+              <a:t> NLP </a:t>
+            </a:r>
+            <a:r>
+              <a:rPr sz="3000" b="1" dirty="0" err="1">
+                <a:solidFill>
+                  <a:srgbClr val="1A365D"/>
+                </a:solidFill>
+              </a:rPr>
+              <a:t>tiếng</a:t>
+            </a:r>
+            <a:r>
+              <a:rPr sz="3000" b="1" dirty="0">
+                <a:solidFill>
+                  <a:srgbClr val="1A365D"/>
+                </a:solidFill>
+              </a:rPr>
+              <a:t> Việt</a:t>
+            </a:r>
+          </a:p>
+          <a:p>
+            <a:pPr algn="ctr"/>
+            <a:r>
+              <a:rPr sz="1500" dirty="0" err="1">
                 <a:solidFill>
                   <a:srgbClr val="4A5568"/>
                 </a:solidFill>
               </a:rPr>
-              <a:t>Đồ án môn Máy học · GVHD: Thầy Cáp Phạm Đình Thăng · Nhóm: &lt;tên thành viên&gt;</a:t>
-            </a:r>
+              <a:t>Đồ</a:t>
+            </a:r>
+            <a:r>
+              <a:rPr sz="1500" dirty="0">
+                <a:solidFill>
+                  <a:srgbClr val="4A5568"/>
+                </a:solidFill>
+              </a:rPr>
+              <a:t> </a:t>
+            </a:r>
+            <a:r>
+              <a:rPr sz="1500" dirty="0" err="1">
+                <a:solidFill>
+                  <a:srgbClr val="4A5568"/>
+                </a:solidFill>
+              </a:rPr>
+              <a:t>án</a:t>
+            </a:r>
+            <a:r>
+              <a:rPr sz="1500" dirty="0">
+                <a:solidFill>
+                  <a:srgbClr val="4A5568"/>
+                </a:solidFill>
+              </a:rPr>
+              <a:t> </a:t>
+            </a:r>
+            <a:r>
+              <a:rPr sz="1500" dirty="0" err="1">
+                <a:solidFill>
+                  <a:srgbClr val="4A5568"/>
+                </a:solidFill>
+              </a:rPr>
+              <a:t>môn</a:t>
+            </a:r>
+            <a:r>
+              <a:rPr sz="1500" dirty="0">
+                <a:solidFill>
+                  <a:srgbClr val="4A5568"/>
+                </a:solidFill>
+              </a:rPr>
+              <a:t> Máy </a:t>
+            </a:r>
+            <a:r>
+              <a:rPr sz="1500" dirty="0" err="1">
+                <a:solidFill>
+                  <a:srgbClr val="4A5568"/>
+                </a:solidFill>
+              </a:rPr>
+              <a:t>học</a:t>
+            </a:r>
+            <a:r>
+              <a:rPr sz="1500" dirty="0">
+                <a:solidFill>
+                  <a:srgbClr val="4A5568"/>
+                </a:solidFill>
+              </a:rPr>
+              <a:t> · GVHD: </a:t>
+            </a:r>
+            <a:r>
+              <a:rPr sz="1500" dirty="0" err="1">
+                <a:solidFill>
+                  <a:srgbClr val="4A5568"/>
+                </a:solidFill>
+              </a:rPr>
+              <a:t>Thầy</a:t>
+            </a:r>
+            <a:r>
+              <a:rPr sz="1500" dirty="0">
+                <a:solidFill>
+                  <a:srgbClr val="4A5568"/>
+                </a:solidFill>
+              </a:rPr>
+              <a:t> </a:t>
+            </a:r>
+            <a:r>
+              <a:rPr sz="1500" dirty="0" err="1">
+                <a:solidFill>
+                  <a:srgbClr val="4A5568"/>
+                </a:solidFill>
+              </a:rPr>
+              <a:t>Cáp</a:t>
+            </a:r>
+            <a:r>
+              <a:rPr sz="1500" dirty="0">
+                <a:solidFill>
+                  <a:srgbClr val="4A5568"/>
+                </a:solidFill>
+              </a:rPr>
+              <a:t> Phạm Đình Thăng · </a:t>
+            </a:r>
+            <a:endParaRPr lang="en-US" sz="1500" dirty="0">
+              <a:solidFill>
+                <a:srgbClr val="4A5568"/>
+              </a:solidFill>
+              <a:ea typeface="Calibri"/>
+              <a:cs typeface="Calibri"/>
+            </a:endParaRPr>
+          </a:p>
+          <a:p>
+            <a:endParaRPr lang="en-US" sz="1500" dirty="0">
+              <a:solidFill>
+                <a:srgbClr val="4A5568"/>
+              </a:solidFill>
+            </a:endParaRPr>
+          </a:p>
+          <a:p>
+            <a:endParaRPr lang="en-US" dirty="0">
+              <a:solidFill>
+                <a:srgbClr val="000000"/>
+              </a:solidFill>
+              <a:ea typeface="Calibri"/>
+              <a:cs typeface="Calibri"/>
+            </a:endParaRPr>
           </a:p>
         </p:txBody>
       </p:sp>
@@ -3193,8 +3460,8 @@
         </p:nvSpPr>
         <p:spPr>
           <a:xfrm>
-            <a:off x="640080" y="2194560"/>
-            <a:ext cx="10972800" cy="5029200"/>
+            <a:off x="640080" y="3639484"/>
+            <a:ext cx="10092187" cy="1313180"/>
           </a:xfrm>
           <a:prstGeom prst="rect">
             <a:avLst/>
@@ -3202,7 +3469,7 @@
           <a:noFill/>
         </p:spPr>
         <p:txBody>
-          <a:bodyPr wrap="square">
+          <a:bodyPr wrap="square" lIns="91440" tIns="45720" rIns="91440" bIns="45720" anchor="t">
             <a:spAutoFit/>
           </a:bodyPr>
           <a:lstStyle/>
@@ -3213,12 +3480,212 @@
               </a:spcAft>
             </a:pPr>
             <a:r>
-              <a:rPr sz="2200">
-                <a:solidFill>
-                  <a:srgbClr val="1A202C"/>
-                </a:solidFill>
-              </a:rPr>
-              <a:t>• Bài toán: câu hỏi đời thường → nhóm quy định → Điều luật cụ thể</a:t>
+              <a:rPr sz="2200" dirty="0">
+                <a:solidFill>
+                  <a:srgbClr val="1A202C"/>
+                </a:solidFill>
+              </a:rPr>
+              <a:t>• </a:t>
+            </a:r>
+            <a:r>
+              <a:rPr sz="2200" dirty="0" err="1">
+                <a:solidFill>
+                  <a:srgbClr val="1A202C"/>
+                </a:solidFill>
+              </a:rPr>
+              <a:t>Bài</a:t>
+            </a:r>
+            <a:r>
+              <a:rPr sz="2200" dirty="0">
+                <a:solidFill>
+                  <a:srgbClr val="1A202C"/>
+                </a:solidFill>
+              </a:rPr>
+              <a:t> </a:t>
+            </a:r>
+            <a:r>
+              <a:rPr sz="2200" dirty="0" err="1">
+                <a:solidFill>
+                  <a:srgbClr val="1A202C"/>
+                </a:solidFill>
+              </a:rPr>
+              <a:t>toán</a:t>
+            </a:r>
+            <a:r>
+              <a:rPr sz="2200" dirty="0">
+                <a:solidFill>
+                  <a:srgbClr val="1A202C"/>
+                </a:solidFill>
+              </a:rPr>
+              <a:t>: </a:t>
+            </a:r>
+            <a:r>
+              <a:rPr sz="2200" dirty="0" err="1">
+                <a:solidFill>
+                  <a:srgbClr val="1A202C"/>
+                </a:solidFill>
+              </a:rPr>
+              <a:t>câu</a:t>
+            </a:r>
+            <a:r>
+              <a:rPr sz="2200" dirty="0">
+                <a:solidFill>
+                  <a:srgbClr val="1A202C"/>
+                </a:solidFill>
+              </a:rPr>
+              <a:t> </a:t>
+            </a:r>
+            <a:r>
+              <a:rPr sz="2200" dirty="0" err="1">
+                <a:solidFill>
+                  <a:srgbClr val="1A202C"/>
+                </a:solidFill>
+              </a:rPr>
+              <a:t>hỏi</a:t>
+            </a:r>
+            <a:r>
+              <a:rPr sz="2200" dirty="0">
+                <a:solidFill>
+                  <a:srgbClr val="1A202C"/>
+                </a:solidFill>
+              </a:rPr>
+              <a:t> </a:t>
+            </a:r>
+            <a:r>
+              <a:rPr sz="2200" dirty="0" err="1">
+                <a:solidFill>
+                  <a:srgbClr val="1A202C"/>
+                </a:solidFill>
+              </a:rPr>
+              <a:t>đời</a:t>
+            </a:r>
+            <a:r>
+              <a:rPr sz="2200" dirty="0">
+                <a:solidFill>
+                  <a:srgbClr val="1A202C"/>
+                </a:solidFill>
+              </a:rPr>
+              <a:t> </a:t>
+            </a:r>
+            <a:r>
+              <a:rPr sz="2200" dirty="0" err="1">
+                <a:solidFill>
+                  <a:srgbClr val="1A202C"/>
+                </a:solidFill>
+              </a:rPr>
+              <a:t>thường</a:t>
+            </a:r>
+            <a:r>
+              <a:rPr sz="2200" dirty="0">
+                <a:solidFill>
+                  <a:srgbClr val="1A202C"/>
+                </a:solidFill>
+              </a:rPr>
+              <a:t> → </a:t>
+            </a:r>
+            <a:r>
+              <a:rPr sz="2200" dirty="0" err="1">
+                <a:solidFill>
+                  <a:srgbClr val="1A202C"/>
+                </a:solidFill>
+              </a:rPr>
+              <a:t>nhóm</a:t>
+            </a:r>
+            <a:r>
+              <a:rPr sz="2200" dirty="0">
+                <a:solidFill>
+                  <a:srgbClr val="1A202C"/>
+                </a:solidFill>
+              </a:rPr>
+              <a:t> </a:t>
+            </a:r>
+            <a:r>
+              <a:rPr sz="2200" dirty="0" err="1">
+                <a:solidFill>
+                  <a:srgbClr val="1A202C"/>
+                </a:solidFill>
+              </a:rPr>
+              <a:t>quy</a:t>
+            </a:r>
+            <a:r>
+              <a:rPr sz="2200" dirty="0">
+                <a:solidFill>
+                  <a:srgbClr val="1A202C"/>
+                </a:solidFill>
+              </a:rPr>
+              <a:t> </a:t>
+            </a:r>
+            <a:r>
+              <a:rPr sz="2200" dirty="0" err="1">
+                <a:solidFill>
+                  <a:srgbClr val="1A202C"/>
+                </a:solidFill>
+              </a:rPr>
+              <a:t>định</a:t>
+            </a:r>
+            <a:r>
+              <a:rPr sz="2200" dirty="0">
+                <a:solidFill>
+                  <a:srgbClr val="1A202C"/>
+                </a:solidFill>
+              </a:rPr>
+              <a:t> → </a:t>
+            </a:r>
+            <a:r>
+              <a:rPr sz="2200" dirty="0" err="1">
+                <a:solidFill>
+                  <a:srgbClr val="1A202C"/>
+                </a:solidFill>
+              </a:rPr>
+              <a:t>Điều</a:t>
+            </a:r>
+            <a:r>
+              <a:rPr sz="2200" dirty="0">
+                <a:solidFill>
+                  <a:srgbClr val="1A202C"/>
+                </a:solidFill>
+              </a:rPr>
+              <a:t> </a:t>
+            </a:r>
+            <a:r>
+              <a:rPr sz="2200" dirty="0" err="1">
+                <a:solidFill>
+                  <a:srgbClr val="1A202C"/>
+                </a:solidFill>
+              </a:rPr>
+              <a:t>luật</a:t>
+            </a:r>
+            <a:r>
+              <a:rPr sz="2200" dirty="0">
+                <a:solidFill>
+                  <a:srgbClr val="1A202C"/>
+                </a:solidFill>
+              </a:rPr>
+              <a:t> </a:t>
+            </a:r>
+            <a:r>
+              <a:rPr sz="2200" dirty="0" err="1">
+                <a:solidFill>
+                  <a:srgbClr val="1A202C"/>
+                </a:solidFill>
+              </a:rPr>
+              <a:t>cụ</a:t>
+            </a:r>
+            <a:r>
+              <a:rPr sz="2200" dirty="0">
+                <a:solidFill>
+                  <a:srgbClr val="1A202C"/>
+                </a:solidFill>
+              </a:rPr>
+              <a:t> </a:t>
+            </a:r>
+            <a:r>
+              <a:rPr sz="2200" dirty="0" err="1">
+                <a:solidFill>
+                  <a:srgbClr val="1A202C"/>
+                </a:solidFill>
+              </a:rPr>
+              <a:t>thể</a:t>
             </a:r>
           </a:p>
           <a:p>
@@ -3228,12 +3695,124 @@
               </a:spcAft>
             </a:pPr>
             <a:r>
-              <a:rPr sz="2200">
-                <a:solidFill>
-                  <a:srgbClr val="1A202C"/>
-                </a:solidFill>
-              </a:rPr>
-              <a:t>• Luật 84/2015/QH13, văn bản hợp nhất 14/VBHN-VPQH (2024), phạm vi Điều 1–62</a:t>
+              <a:rPr sz="2200" dirty="0">
+                <a:solidFill>
+                  <a:srgbClr val="1A202C"/>
+                </a:solidFill>
+              </a:rPr>
+              <a:t>• </a:t>
+            </a:r>
+            <a:r>
+              <a:rPr sz="2200" dirty="0" err="1">
+                <a:solidFill>
+                  <a:srgbClr val="1A202C"/>
+                </a:solidFill>
+              </a:rPr>
+              <a:t>Luật</a:t>
+            </a:r>
+            <a:r>
+              <a:rPr sz="2200" dirty="0">
+                <a:solidFill>
+                  <a:srgbClr val="1A202C"/>
+                </a:solidFill>
+              </a:rPr>
+              <a:t> 84/2015/QH13, </a:t>
+            </a:r>
+            <a:r>
+              <a:rPr sz="2200" dirty="0" err="1">
+                <a:solidFill>
+                  <a:srgbClr val="1A202C"/>
+                </a:solidFill>
+              </a:rPr>
+              <a:t>văn</a:t>
+            </a:r>
+            <a:r>
+              <a:rPr sz="2200" dirty="0">
+                <a:solidFill>
+                  <a:srgbClr val="1A202C"/>
+                </a:solidFill>
+              </a:rPr>
+              <a:t> </a:t>
+            </a:r>
+            <a:r>
+              <a:rPr sz="2200" dirty="0" err="1">
+                <a:solidFill>
+                  <a:srgbClr val="1A202C"/>
+                </a:solidFill>
+              </a:rPr>
+              <a:t>bản</a:t>
+            </a:r>
+            <a:r>
+              <a:rPr sz="2200" dirty="0">
+                <a:solidFill>
+                  <a:srgbClr val="1A202C"/>
+                </a:solidFill>
+              </a:rPr>
+              <a:t> </a:t>
+            </a:r>
+            <a:r>
+              <a:rPr sz="2200" dirty="0" err="1">
+                <a:solidFill>
+                  <a:srgbClr val="1A202C"/>
+                </a:solidFill>
+              </a:rPr>
+              <a:t>hợp</a:t>
+            </a:r>
+            <a:r>
+              <a:rPr sz="2200" dirty="0">
+                <a:solidFill>
+                  <a:srgbClr val="1A202C"/>
+                </a:solidFill>
+              </a:rPr>
+              <a:t> </a:t>
+            </a:r>
+            <a:r>
+              <a:rPr sz="2200" dirty="0" err="1">
+                <a:solidFill>
+                  <a:srgbClr val="1A202C"/>
+                </a:solidFill>
+              </a:rPr>
+              <a:t>nhất</a:t>
+            </a:r>
+            <a:r>
+              <a:rPr sz="2200" dirty="0">
+                <a:solidFill>
+                  <a:srgbClr val="1A202C"/>
+                </a:solidFill>
+              </a:rPr>
+              <a:t> 14/VBHN-VPQH (2024), </a:t>
+            </a:r>
+            <a:r>
+              <a:rPr sz="2200" dirty="0" err="1">
+                <a:solidFill>
+                  <a:srgbClr val="1A202C"/>
+                </a:solidFill>
+              </a:rPr>
+              <a:t>phạm</a:t>
+            </a:r>
+            <a:r>
+              <a:rPr sz="2200" dirty="0">
+                <a:solidFill>
+                  <a:srgbClr val="1A202C"/>
+                </a:solidFill>
+              </a:rPr>
+              <a:t> vi </a:t>
+            </a:r>
+            <a:r>
+              <a:rPr sz="2200" dirty="0" err="1">
+                <a:solidFill>
+                  <a:srgbClr val="1A202C"/>
+                </a:solidFill>
+              </a:rPr>
+              <a:t>Điều</a:t>
+            </a:r>
+            <a:r>
+              <a:rPr sz="2200" dirty="0">
+                <a:solidFill>
+                  <a:srgbClr val="1A202C"/>
+                </a:solidFill>
+              </a:rPr>
+              <a:t> 1–62</a:t>
             </a:r>
           </a:p>
           <a:p>
@@ -3243,13 +3822,303 @@
               </a:spcAft>
             </a:pPr>
             <a:r>
-              <a:rPr sz="2200">
-                <a:solidFill>
-                  <a:srgbClr val="1A202C"/>
-                </a:solidFill>
-              </a:rPr>
-              <a:t>• Cốt lõi Machine Learning: phân loại văn bản 8 lớp, so sánh 4 mô hình</a:t>
-            </a:r>
+              <a:rPr sz="2200" dirty="0">
+                <a:solidFill>
+                  <a:srgbClr val="1A202C"/>
+                </a:solidFill>
+              </a:rPr>
+              <a:t>• </a:t>
+            </a:r>
+            <a:r>
+              <a:rPr sz="2200" dirty="0" err="1">
+                <a:solidFill>
+                  <a:srgbClr val="1A202C"/>
+                </a:solidFill>
+              </a:rPr>
+              <a:t>Cốt</a:t>
+            </a:r>
+            <a:r>
+              <a:rPr sz="2200" dirty="0">
+                <a:solidFill>
+                  <a:srgbClr val="1A202C"/>
+                </a:solidFill>
+              </a:rPr>
+              <a:t> </a:t>
+            </a:r>
+            <a:r>
+              <a:rPr sz="2200" dirty="0" err="1">
+                <a:solidFill>
+                  <a:srgbClr val="1A202C"/>
+                </a:solidFill>
+              </a:rPr>
+              <a:t>lõi</a:t>
+            </a:r>
+            <a:r>
+              <a:rPr sz="2200" dirty="0">
+                <a:solidFill>
+                  <a:srgbClr val="1A202C"/>
+                </a:solidFill>
+              </a:rPr>
+              <a:t> Machine Learning: </a:t>
+            </a:r>
+            <a:r>
+              <a:rPr sz="2200" dirty="0" err="1">
+                <a:solidFill>
+                  <a:srgbClr val="1A202C"/>
+                </a:solidFill>
+              </a:rPr>
+              <a:t>phân</a:t>
+            </a:r>
+            <a:r>
+              <a:rPr sz="2200" dirty="0">
+                <a:solidFill>
+                  <a:srgbClr val="1A202C"/>
+                </a:solidFill>
+              </a:rPr>
+              <a:t> </a:t>
+            </a:r>
+            <a:r>
+              <a:rPr sz="2200" dirty="0" err="1">
+                <a:solidFill>
+                  <a:srgbClr val="1A202C"/>
+                </a:solidFill>
+              </a:rPr>
+              <a:t>loại</a:t>
+            </a:r>
+            <a:r>
+              <a:rPr sz="2200" dirty="0">
+                <a:solidFill>
+                  <a:srgbClr val="1A202C"/>
+                </a:solidFill>
+              </a:rPr>
+              <a:t> </a:t>
+            </a:r>
+            <a:r>
+              <a:rPr sz="2200" dirty="0" err="1">
+                <a:solidFill>
+                  <a:srgbClr val="1A202C"/>
+                </a:solidFill>
+              </a:rPr>
+              <a:t>văn</a:t>
+            </a:r>
+            <a:r>
+              <a:rPr sz="2200" dirty="0">
+                <a:solidFill>
+                  <a:srgbClr val="1A202C"/>
+                </a:solidFill>
+              </a:rPr>
+              <a:t> </a:t>
+            </a:r>
+            <a:r>
+              <a:rPr sz="2200" dirty="0" err="1">
+                <a:solidFill>
+                  <a:srgbClr val="1A202C"/>
+                </a:solidFill>
+              </a:rPr>
+              <a:t>bản</a:t>
+            </a:r>
+            <a:r>
+              <a:rPr sz="2200" dirty="0">
+                <a:solidFill>
+                  <a:srgbClr val="1A202C"/>
+                </a:solidFill>
+              </a:rPr>
+              <a:t> 8 </a:t>
+            </a:r>
+            <a:r>
+              <a:rPr sz="2200" dirty="0" err="1">
+                <a:solidFill>
+                  <a:srgbClr val="1A202C"/>
+                </a:solidFill>
+              </a:rPr>
+              <a:t>lớp</a:t>
+            </a:r>
+            <a:r>
+              <a:rPr sz="2200" dirty="0">
+                <a:solidFill>
+                  <a:srgbClr val="1A202C"/>
+                </a:solidFill>
+              </a:rPr>
+              <a:t>, so </a:t>
+            </a:r>
+            <a:r>
+              <a:rPr sz="2200" dirty="0" err="1">
+                <a:solidFill>
+                  <a:srgbClr val="1A202C"/>
+                </a:solidFill>
+              </a:rPr>
+              <a:t>sánh</a:t>
+            </a:r>
+            <a:r>
+              <a:rPr sz="2200" dirty="0">
+                <a:solidFill>
+                  <a:srgbClr val="1A202C"/>
+                </a:solidFill>
+              </a:rPr>
+              <a:t> 4 </a:t>
+            </a:r>
+            <a:r>
+              <a:rPr sz="2200" dirty="0" err="1">
+                <a:solidFill>
+                  <a:srgbClr val="1A202C"/>
+                </a:solidFill>
+              </a:rPr>
+              <a:t>mô</a:t>
+            </a:r>
+            <a:r>
+              <a:rPr sz="2200" dirty="0">
+                <a:solidFill>
+                  <a:srgbClr val="1A202C"/>
+                </a:solidFill>
+              </a:rPr>
+              <a:t> </a:t>
+            </a:r>
+            <a:r>
+              <a:rPr sz="2200" dirty="0" err="1">
+                <a:solidFill>
+                  <a:srgbClr val="1A202C"/>
+                </a:solidFill>
+              </a:rPr>
+              <a:t>hình</a:t>
+            </a:r>
+          </a:p>
+        </p:txBody>
+      </p:sp>
+      <p:sp>
+        <p:nvSpPr>
+          <p:cNvPr id="5" name="TextBox 4">
+            <a:extLst>
+              <a:ext uri="{FF2B5EF4-FFF2-40B4-BE49-F238E27FC236}">
+                <a16:creationId xmlns:a16="http://schemas.microsoft.com/office/drawing/2014/main" id="{904D5802-8301-55C2-E595-47FF63AA6033}"/>
+              </a:ext>
+            </a:extLst>
+          </p:cNvPr>
+          <p:cNvSpPr txBox="1"/>
+          <p:nvPr/>
+        </p:nvSpPr>
+        <p:spPr>
+          <a:xfrm>
+            <a:off x="4189705" y="1951869"/>
+            <a:ext cx="2994999" cy="1477328"/>
+          </a:xfrm>
+          <a:prstGeom prst="rect">
+            <a:avLst/>
+          </a:prstGeom>
+          <a:noFill/>
+        </p:spPr>
+        <p:txBody>
+          <a:bodyPr wrap="square" lIns="91440" tIns="45720" rIns="91440" bIns="45720" anchor="t">
+            <a:spAutoFit/>
+          </a:bodyPr>
+          <a:lstStyle/>
+          <a:p>
+            <a:r>
+              <a:rPr sz="1500" dirty="0" err="1">
+                <a:solidFill>
+                  <a:srgbClr val="4A5568"/>
+                </a:solidFill>
+              </a:rPr>
+              <a:t>Nhóm</a:t>
+            </a:r>
+            <a:r>
+              <a:rPr sz="1500" dirty="0">
+                <a:solidFill>
+                  <a:srgbClr val="4A5568"/>
+                </a:solidFill>
+              </a:rPr>
+              <a:t>: </a:t>
+            </a:r>
+            <a:r>
+              <a:rPr lang="en-US" sz="1500" dirty="0">
+                <a:solidFill>
+                  <a:srgbClr val="4A5568"/>
+                </a:solidFill>
+              </a:rPr>
+              <a:t>27</a:t>
+            </a:r>
+            <a:endParaRPr lang="en-US" sz="1500">
+              <a:solidFill>
+                <a:srgbClr val="4A5568"/>
+              </a:solidFill>
+              <a:ea typeface="Calibri"/>
+              <a:cs typeface="Calibri"/>
+            </a:endParaRPr>
+          </a:p>
+          <a:p>
+            <a:r>
+              <a:rPr lang="en-US" sz="1500" dirty="0" err="1">
+                <a:solidFill>
+                  <a:srgbClr val="4A5568"/>
+                </a:solidFill>
+                <a:ea typeface="+mn-lt"/>
+                <a:cs typeface="+mn-lt"/>
+              </a:rPr>
+              <a:t>Đỗ</a:t>
+            </a:r>
+            <a:r>
+              <a:rPr lang="en-US" sz="1500" dirty="0">
+                <a:solidFill>
+                  <a:srgbClr val="4A5568"/>
+                </a:solidFill>
+                <a:ea typeface="+mn-lt"/>
+                <a:cs typeface="+mn-lt"/>
+              </a:rPr>
+              <a:t> Quốc Hoàng 26410043</a:t>
+            </a:r>
+            <a:endParaRPr dirty="0">
+              <a:ea typeface="Calibri"/>
+              <a:cs typeface="Calibri"/>
+            </a:endParaRPr>
+          </a:p>
+          <a:p>
+            <a:r>
+              <a:rPr lang="en-US" sz="1500" dirty="0">
+                <a:solidFill>
+                  <a:srgbClr val="4A5568"/>
+                </a:solidFill>
+                <a:ea typeface="+mn-lt"/>
+                <a:cs typeface="+mn-lt"/>
+              </a:rPr>
+              <a:t>Nguyễn Trí Toàn 26410135</a:t>
+            </a:r>
+            <a:endParaRPr lang="en-US" dirty="0">
+              <a:ea typeface="Calibri"/>
+              <a:cs typeface="Calibri"/>
+            </a:endParaRPr>
+          </a:p>
+          <a:p>
+            <a:r>
+              <a:rPr lang="en-US" sz="1500" dirty="0">
+                <a:solidFill>
+                  <a:srgbClr val="4A5568"/>
+                </a:solidFill>
+                <a:ea typeface="+mn-lt"/>
+                <a:cs typeface="+mn-lt"/>
+              </a:rPr>
+              <a:t>Nguyễn Văn Thái 26410108</a:t>
+            </a:r>
+            <a:endParaRPr lang="en-US" dirty="0">
+              <a:ea typeface="Calibri"/>
+              <a:cs typeface="Calibri"/>
+            </a:endParaRPr>
+          </a:p>
+          <a:p>
+            <a:endParaRPr lang="en-US" sz="1500" dirty="0">
+              <a:solidFill>
+                <a:srgbClr val="4A5568"/>
+              </a:solidFill>
+              <a:ea typeface="Calibri"/>
+              <a:cs typeface="Calibri"/>
+            </a:endParaRPr>
+          </a:p>
+          <a:p>
+            <a:endParaRPr lang="en-US" sz="1500" dirty="0">
+              <a:solidFill>
+                <a:srgbClr val="4A5568"/>
+              </a:solidFill>
+              <a:ea typeface="Calibri"/>
+              <a:cs typeface="Calibri"/>
+            </a:endParaRPr>
           </a:p>
         </p:txBody>
       </p:sp>
@@ -3262,7 +4131,7 @@
 </file>
 
 <file path=ppt/slides/slide10.xml><?xml version="1.0" encoding="utf-8"?>
-<p:sld xmlns:a="http://schemas.openxmlformats.org/drawingml/2006/main" xmlns:p="http://schemas.openxmlformats.org/presentationml/2006/main" xmlns:r="http://schemas.openxmlformats.org/officeDocument/2006/relationships">
+<p:sld xmlns:a="http://schemas.openxmlformats.org/drawingml/2006/main" xmlns:r="http://schemas.openxmlformats.org/officeDocument/2006/relationships" xmlns:p="http://schemas.openxmlformats.org/presentationml/2006/main">
   <p:cSld>
     <p:spTree>
       <p:nvGrpSpPr>
@@ -3270,7 +4139,14 @@
         <p:cNvGrpSpPr/>
         <p:nvPr/>
       </p:nvGrpSpPr>
-      <p:grpSpPr/>
+      <p:grpSpPr>
+        <a:xfrm>
+          <a:off x="0" y="0"/>
+          <a:ext cx="0" cy="0"/>
+          <a:chOff x="0" y="0"/>
+          <a:chExt cx="0" cy="0"/>
+        </a:xfrm>
+      </p:grpSpPr>
       <p:sp>
         <p:nvSpPr>
           <p:cNvPr id="2" name="Rectangle 1"/>
@@ -3311,6 +4187,7 @@
           <a:lstStyle/>
           <a:p>
             <a:pPr algn="ctr"/>
+            <a:endParaRPr/>
           </a:p>
         </p:txBody>
       </p:sp>
@@ -3366,9 +4243,27 @@
                 <a:tableStyleId>{5C22544A-7EE6-4342-B048-85BDC9FD1C3A}</a:tableStyleId>
               </a:tblPr>
               <a:tblGrid>
-                <a:gridCol w="2286000"/>
-                <a:gridCol w="2286000"/>
-                <a:gridCol w="2286000"/>
+                <a:gridCol w="2286000">
+                  <a:extLst>
+                    <a:ext uri="{9D8B030D-6E8A-4147-A177-3AD203B41FA5}">
+                      <a16:colId xmlns:a16="http://schemas.microsoft.com/office/drawing/2014/main" val="20000"/>
+                    </a:ext>
+                  </a:extLst>
+                </a:gridCol>
+                <a:gridCol w="2286000">
+                  <a:extLst>
+                    <a:ext uri="{9D8B030D-6E8A-4147-A177-3AD203B41FA5}">
+                      <a16:colId xmlns:a16="http://schemas.microsoft.com/office/drawing/2014/main" val="20001"/>
+                    </a:ext>
+                  </a:extLst>
+                </a:gridCol>
+                <a:gridCol w="2286000">
+                  <a:extLst>
+                    <a:ext uri="{9D8B030D-6E8A-4147-A177-3AD203B41FA5}">
+                      <a16:colId xmlns:a16="http://schemas.microsoft.com/office/drawing/2014/main" val="20002"/>
+                    </a:ext>
+                  </a:extLst>
+                </a:gridCol>
               </a:tblGrid>
               <a:tr h="384048">
                 <a:tc>
@@ -3410,6 +4305,11 @@
                   </a:txBody>
                   <a:tcPr/>
                 </a:tc>
+                <a:extLst>
+                  <a:ext uri="{0D108BD9-81ED-4DB2-BD59-A6C34878D82A}">
+                    <a16:rowId xmlns:a16="http://schemas.microsoft.com/office/drawing/2014/main" val="10000"/>
+                  </a:ext>
+                </a:extLst>
               </a:tr>
               <a:tr h="384048">
                 <a:tc>
@@ -3451,6 +4351,11 @@
                   </a:txBody>
                   <a:tcPr/>
                 </a:tc>
+                <a:extLst>
+                  <a:ext uri="{0D108BD9-81ED-4DB2-BD59-A6C34878D82A}">
+                    <a16:rowId xmlns:a16="http://schemas.microsoft.com/office/drawing/2014/main" val="10001"/>
+                  </a:ext>
+                </a:extLst>
               </a:tr>
               <a:tr h="384048">
                 <a:tc>
@@ -3492,6 +4397,11 @@
                   </a:txBody>
                   <a:tcPr/>
                 </a:tc>
+                <a:extLst>
+                  <a:ext uri="{0D108BD9-81ED-4DB2-BD59-A6C34878D82A}">
+                    <a16:rowId xmlns:a16="http://schemas.microsoft.com/office/drawing/2014/main" val="10002"/>
+                  </a:ext>
+                </a:extLst>
               </a:tr>
               <a:tr h="384048">
                 <a:tc>
@@ -3533,6 +4443,11 @@
                   </a:txBody>
                   <a:tcPr/>
                 </a:tc>
+                <a:extLst>
+                  <a:ext uri="{0D108BD9-81ED-4DB2-BD59-A6C34878D82A}">
+                    <a16:rowId xmlns:a16="http://schemas.microsoft.com/office/drawing/2014/main" val="10003"/>
+                  </a:ext>
+                </a:extLst>
               </a:tr>
               <a:tr h="384048">
                 <a:tc>
@@ -3574,6 +4489,11 @@
                   </a:txBody>
                   <a:tcPr/>
                 </a:tc>
+                <a:extLst>
+                  <a:ext uri="{0D108BD9-81ED-4DB2-BD59-A6C34878D82A}">
+                    <a16:rowId xmlns:a16="http://schemas.microsoft.com/office/drawing/2014/main" val="10004"/>
+                  </a:ext>
+                </a:extLst>
               </a:tr>
               <a:tr h="384048">
                 <a:tc>
@@ -3615,6 +4535,11 @@
                   </a:txBody>
                   <a:tcPr/>
                 </a:tc>
+                <a:extLst>
+                  <a:ext uri="{0D108BD9-81ED-4DB2-BD59-A6C34878D82A}">
+                    <a16:rowId xmlns:a16="http://schemas.microsoft.com/office/drawing/2014/main" val="10005"/>
+                  </a:ext>
+                </a:extLst>
               </a:tr>
               <a:tr h="384048">
                 <a:tc>
@@ -3656,6 +4581,11 @@
                   </a:txBody>
                   <a:tcPr/>
                 </a:tc>
+                <a:extLst>
+                  <a:ext uri="{0D108BD9-81ED-4DB2-BD59-A6C34878D82A}">
+                    <a16:rowId xmlns:a16="http://schemas.microsoft.com/office/drawing/2014/main" val="10006"/>
+                  </a:ext>
+                </a:extLst>
               </a:tr>
               <a:tr h="384048">
                 <a:tc>
@@ -3697,6 +4627,11 @@
                   </a:txBody>
                   <a:tcPr/>
                 </a:tc>
+                <a:extLst>
+                  <a:ext uri="{0D108BD9-81ED-4DB2-BD59-A6C34878D82A}">
+                    <a16:rowId xmlns:a16="http://schemas.microsoft.com/office/drawing/2014/main" val="10007"/>
+                  </a:ext>
+                </a:extLst>
               </a:tr>
             </a:tbl>
           </a:graphicData>
@@ -3794,7 +4729,7 @@
 </file>
 
 <file path=ppt/slides/slide11.xml><?xml version="1.0" encoding="utf-8"?>
-<p:sld xmlns:a="http://schemas.openxmlformats.org/drawingml/2006/main" xmlns:p="http://schemas.openxmlformats.org/presentationml/2006/main" xmlns:r="http://schemas.openxmlformats.org/officeDocument/2006/relationships">
+<p:sld xmlns:a="http://schemas.openxmlformats.org/drawingml/2006/main" xmlns:r="http://schemas.openxmlformats.org/officeDocument/2006/relationships" xmlns:p="http://schemas.openxmlformats.org/presentationml/2006/main">
   <p:cSld>
     <p:spTree>
       <p:nvGrpSpPr>
@@ -3802,7 +4737,14 @@
         <p:cNvGrpSpPr/>
         <p:nvPr/>
       </p:nvGrpSpPr>
-      <p:grpSpPr/>
+      <p:grpSpPr>
+        <a:xfrm>
+          <a:off x="0" y="0"/>
+          <a:ext cx="0" cy="0"/>
+          <a:chOff x="0" y="0"/>
+          <a:chExt cx="0" cy="0"/>
+        </a:xfrm>
+      </p:grpSpPr>
       <p:sp>
         <p:nvSpPr>
           <p:cNvPr id="2" name="Rectangle 1"/>
@@ -3843,6 +4785,7 @@
           <a:lstStyle/>
           <a:p>
             <a:pPr algn="ctr"/>
+            <a:endParaRPr/>
           </a:p>
         </p:txBody>
       </p:sp>
@@ -3971,7 +4914,7 @@
 </file>
 
 <file path=ppt/slides/slide12.xml><?xml version="1.0" encoding="utf-8"?>
-<p:sld xmlns:a="http://schemas.openxmlformats.org/drawingml/2006/main" xmlns:p="http://schemas.openxmlformats.org/presentationml/2006/main" xmlns:r="http://schemas.openxmlformats.org/officeDocument/2006/relationships">
+<p:sld xmlns:a="http://schemas.openxmlformats.org/drawingml/2006/main" xmlns:r="http://schemas.openxmlformats.org/officeDocument/2006/relationships" xmlns:p="http://schemas.openxmlformats.org/presentationml/2006/main">
   <p:cSld>
     <p:spTree>
       <p:nvGrpSpPr>
@@ -3979,7 +4922,14 @@
         <p:cNvGrpSpPr/>
         <p:nvPr/>
       </p:nvGrpSpPr>
-      <p:grpSpPr/>
+      <p:grpSpPr>
+        <a:xfrm>
+          <a:off x="0" y="0"/>
+          <a:ext cx="0" cy="0"/>
+          <a:chOff x="0" y="0"/>
+          <a:chExt cx="0" cy="0"/>
+        </a:xfrm>
+      </p:grpSpPr>
       <p:sp>
         <p:nvSpPr>
           <p:cNvPr id="2" name="Rectangle 1"/>
@@ -4020,6 +4970,7 @@
           <a:lstStyle/>
           <a:p>
             <a:pPr algn="ctr"/>
+            <a:endParaRPr/>
           </a:p>
         </p:txBody>
       </p:sp>
@@ -4075,7 +5026,7 @@
 </file>
 
 <file path=ppt/slides/slide2.xml><?xml version="1.0" encoding="utf-8"?>
-<p:sld xmlns:a="http://schemas.openxmlformats.org/drawingml/2006/main" xmlns:p="http://schemas.openxmlformats.org/presentationml/2006/main" xmlns:r="http://schemas.openxmlformats.org/officeDocument/2006/relationships">
+<p:sld xmlns:a="http://schemas.openxmlformats.org/drawingml/2006/main" xmlns:r="http://schemas.openxmlformats.org/officeDocument/2006/relationships" xmlns:p="http://schemas.openxmlformats.org/presentationml/2006/main">
   <p:cSld>
     <p:spTree>
       <p:nvGrpSpPr>
@@ -4083,7 +5034,14 @@
         <p:cNvGrpSpPr/>
         <p:nvPr/>
       </p:nvGrpSpPr>
-      <p:grpSpPr/>
+      <p:grpSpPr>
+        <a:xfrm>
+          <a:off x="0" y="0"/>
+          <a:ext cx="0" cy="0"/>
+          <a:chOff x="0" y="0"/>
+          <a:chExt cx="0" cy="0"/>
+        </a:xfrm>
+      </p:grpSpPr>
       <p:sp>
         <p:nvSpPr>
           <p:cNvPr id="2" name="Rectangle 1"/>
@@ -4124,6 +5082,7 @@
           <a:lstStyle/>
           <a:p>
             <a:pPr algn="ctr"/>
+            <a:endParaRPr/>
           </a:p>
         </p:txBody>
       </p:sp>
@@ -4267,7 +5226,7 @@
 </file>
 
 <file path=ppt/slides/slide3.xml><?xml version="1.0" encoding="utf-8"?>
-<p:sld xmlns:a="http://schemas.openxmlformats.org/drawingml/2006/main" xmlns:p="http://schemas.openxmlformats.org/presentationml/2006/main" xmlns:r="http://schemas.openxmlformats.org/officeDocument/2006/relationships">
+<p:sld xmlns:a="http://schemas.openxmlformats.org/drawingml/2006/main" xmlns:r="http://schemas.openxmlformats.org/officeDocument/2006/relationships" xmlns:p="http://schemas.openxmlformats.org/presentationml/2006/main">
   <p:cSld>
     <p:spTree>
       <p:nvGrpSpPr>
@@ -4275,7 +5234,14 @@
         <p:cNvGrpSpPr/>
         <p:nvPr/>
       </p:nvGrpSpPr>
-      <p:grpSpPr/>
+      <p:grpSpPr>
+        <a:xfrm>
+          <a:off x="0" y="0"/>
+          <a:ext cx="0" cy="0"/>
+          <a:chOff x="0" y="0"/>
+          <a:chExt cx="0" cy="0"/>
+        </a:xfrm>
+      </p:grpSpPr>
       <p:sp>
         <p:nvSpPr>
           <p:cNvPr id="2" name="Rectangle 1"/>
@@ -4316,6 +5282,7 @@
           <a:lstStyle/>
           <a:p>
             <a:pPr algn="ctr"/>
+            <a:endParaRPr/>
           </a:p>
         </p:txBody>
       </p:sp>
@@ -4372,7 +5339,7 @@
         </p:nvGraphicFramePr>
         <p:xfrm>
           <a:off x="548640" y="1554480"/>
-          <a:ext cx="11064240" cy="3456432"/>
+          <a:ext cx="11064240" cy="3870960"/>
         </p:xfrm>
         <a:graphic>
           <a:graphicData uri="http://schemas.openxmlformats.org/drawingml/2006/table">
@@ -4381,10 +5348,34 @@
                 <a:tableStyleId>{5C22544A-7EE6-4342-B048-85BDC9FD1C3A}</a:tableStyleId>
               </a:tblPr>
               <a:tblGrid>
-                <a:gridCol w="2766060"/>
-                <a:gridCol w="2766060"/>
-                <a:gridCol w="2766060"/>
-                <a:gridCol w="2766060"/>
+                <a:gridCol w="2766060">
+                  <a:extLst>
+                    <a:ext uri="{9D8B030D-6E8A-4147-A177-3AD203B41FA5}">
+                      <a16:colId xmlns:a16="http://schemas.microsoft.com/office/drawing/2014/main" val="20000"/>
+                    </a:ext>
+                  </a:extLst>
+                </a:gridCol>
+                <a:gridCol w="2766060">
+                  <a:extLst>
+                    <a:ext uri="{9D8B030D-6E8A-4147-A177-3AD203B41FA5}">
+                      <a16:colId xmlns:a16="http://schemas.microsoft.com/office/drawing/2014/main" val="20001"/>
+                    </a:ext>
+                  </a:extLst>
+                </a:gridCol>
+                <a:gridCol w="2766060">
+                  <a:extLst>
+                    <a:ext uri="{9D8B030D-6E8A-4147-A177-3AD203B41FA5}">
+                      <a16:colId xmlns:a16="http://schemas.microsoft.com/office/drawing/2014/main" val="20002"/>
+                    </a:ext>
+                  </a:extLst>
+                </a:gridCol>
+                <a:gridCol w="2766060">
+                  <a:extLst>
+                    <a:ext uri="{9D8B030D-6E8A-4147-A177-3AD203B41FA5}">
+                      <a16:colId xmlns:a16="http://schemas.microsoft.com/office/drawing/2014/main" val="20003"/>
+                    </a:ext>
+                  </a:extLst>
+                </a:gridCol>
               </a:tblGrid>
               <a:tr h="384048">
                 <a:tc>
@@ -4439,6 +5430,11 @@
                   </a:txBody>
                   <a:tcPr/>
                 </a:tc>
+                <a:extLst>
+                  <a:ext uri="{0D108BD9-81ED-4DB2-BD59-A6C34878D82A}">
+                    <a16:rowId xmlns:a16="http://schemas.microsoft.com/office/drawing/2014/main" val="10000"/>
+                  </a:ext>
+                </a:extLst>
               </a:tr>
               <a:tr h="384048">
                 <a:tc>
@@ -4493,6 +5489,11 @@
                   </a:txBody>
                   <a:tcPr/>
                 </a:tc>
+                <a:extLst>
+                  <a:ext uri="{0D108BD9-81ED-4DB2-BD59-A6C34878D82A}">
+                    <a16:rowId xmlns:a16="http://schemas.microsoft.com/office/drawing/2014/main" val="10001"/>
+                  </a:ext>
+                </a:extLst>
               </a:tr>
               <a:tr h="384048">
                 <a:tc>
@@ -4547,6 +5548,11 @@
                   </a:txBody>
                   <a:tcPr/>
                 </a:tc>
+                <a:extLst>
+                  <a:ext uri="{0D108BD9-81ED-4DB2-BD59-A6C34878D82A}">
+                    <a16:rowId xmlns:a16="http://schemas.microsoft.com/office/drawing/2014/main" val="10002"/>
+                  </a:ext>
+                </a:extLst>
               </a:tr>
               <a:tr h="384048">
                 <a:tc>
@@ -4601,6 +5607,11 @@
                   </a:txBody>
                   <a:tcPr/>
                 </a:tc>
+                <a:extLst>
+                  <a:ext uri="{0D108BD9-81ED-4DB2-BD59-A6C34878D82A}">
+                    <a16:rowId xmlns:a16="http://schemas.microsoft.com/office/drawing/2014/main" val="10003"/>
+                  </a:ext>
+                </a:extLst>
               </a:tr>
               <a:tr h="384048">
                 <a:tc>
@@ -4655,6 +5666,11 @@
                   </a:txBody>
                   <a:tcPr/>
                 </a:tc>
+                <a:extLst>
+                  <a:ext uri="{0D108BD9-81ED-4DB2-BD59-A6C34878D82A}">
+                    <a16:rowId xmlns:a16="http://schemas.microsoft.com/office/drawing/2014/main" val="10004"/>
+                  </a:ext>
+                </a:extLst>
               </a:tr>
               <a:tr h="384048">
                 <a:tc>
@@ -4709,6 +5725,11 @@
                   </a:txBody>
                   <a:tcPr/>
                 </a:tc>
+                <a:extLst>
+                  <a:ext uri="{0D108BD9-81ED-4DB2-BD59-A6C34878D82A}">
+                    <a16:rowId xmlns:a16="http://schemas.microsoft.com/office/drawing/2014/main" val="10005"/>
+                  </a:ext>
+                </a:extLst>
               </a:tr>
               <a:tr h="384048">
                 <a:tc>
@@ -4763,6 +5784,11 @@
                   </a:txBody>
                   <a:tcPr/>
                 </a:tc>
+                <a:extLst>
+                  <a:ext uri="{0D108BD9-81ED-4DB2-BD59-A6C34878D82A}">
+                    <a16:rowId xmlns:a16="http://schemas.microsoft.com/office/drawing/2014/main" val="10006"/>
+                  </a:ext>
+                </a:extLst>
               </a:tr>
               <a:tr h="384048">
                 <a:tc>
@@ -4817,6 +5843,11 @@
                   </a:txBody>
                   <a:tcPr/>
                 </a:tc>
+                <a:extLst>
+                  <a:ext uri="{0D108BD9-81ED-4DB2-BD59-A6C34878D82A}">
+                    <a16:rowId xmlns:a16="http://schemas.microsoft.com/office/drawing/2014/main" val="10007"/>
+                  </a:ext>
+                </a:extLst>
               </a:tr>
               <a:tr h="384048">
                 <a:tc>
@@ -4871,6 +5902,11 @@
                   </a:txBody>
                   <a:tcPr/>
                 </a:tc>
+                <a:extLst>
+                  <a:ext uri="{0D108BD9-81ED-4DB2-BD59-A6C34878D82A}">
+                    <a16:rowId xmlns:a16="http://schemas.microsoft.com/office/drawing/2014/main" val="10008"/>
+                  </a:ext>
+                </a:extLst>
               </a:tr>
             </a:tbl>
           </a:graphicData>
@@ -4885,7 +5921,7 @@
 </file>
 
 <file path=ppt/slides/slide4.xml><?xml version="1.0" encoding="utf-8"?>
-<p:sld xmlns:a="http://schemas.openxmlformats.org/drawingml/2006/main" xmlns:p="http://schemas.openxmlformats.org/presentationml/2006/main" xmlns:r="http://schemas.openxmlformats.org/officeDocument/2006/relationships">
+<p:sld xmlns:a="http://schemas.openxmlformats.org/drawingml/2006/main" xmlns:r="http://schemas.openxmlformats.org/officeDocument/2006/relationships" xmlns:p="http://schemas.openxmlformats.org/presentationml/2006/main">
   <p:cSld>
     <p:spTree>
       <p:nvGrpSpPr>
@@ -4893,7 +5929,14 @@
         <p:cNvGrpSpPr/>
         <p:nvPr/>
       </p:nvGrpSpPr>
-      <p:grpSpPr/>
+      <p:grpSpPr>
+        <a:xfrm>
+          <a:off x="0" y="0"/>
+          <a:ext cx="0" cy="0"/>
+          <a:chOff x="0" y="0"/>
+          <a:chExt cx="0" cy="0"/>
+        </a:xfrm>
+      </p:grpSpPr>
       <p:sp>
         <p:nvSpPr>
           <p:cNvPr id="2" name="Rectangle 1"/>
@@ -4934,6 +5977,7 @@
           <a:lstStyle/>
           <a:p>
             <a:pPr algn="ctr"/>
+            <a:endParaRPr/>
           </a:p>
         </p:txBody>
       </p:sp>
@@ -5111,7 +6155,7 @@
 </file>
 
 <file path=ppt/slides/slide5.xml><?xml version="1.0" encoding="utf-8"?>
-<p:sld xmlns:a="http://schemas.openxmlformats.org/drawingml/2006/main" xmlns:p="http://schemas.openxmlformats.org/presentationml/2006/main" xmlns:r="http://schemas.openxmlformats.org/officeDocument/2006/relationships">
+<p:sld xmlns:a="http://schemas.openxmlformats.org/drawingml/2006/main" xmlns:r="http://schemas.openxmlformats.org/officeDocument/2006/relationships" xmlns:p="http://schemas.openxmlformats.org/presentationml/2006/main">
   <p:cSld>
     <p:spTree>
       <p:nvGrpSpPr>
@@ -5119,7 +6163,14 @@
         <p:cNvGrpSpPr/>
         <p:nvPr/>
       </p:nvGrpSpPr>
-      <p:grpSpPr/>
+      <p:grpSpPr>
+        <a:xfrm>
+          <a:off x="0" y="0"/>
+          <a:ext cx="0" cy="0"/>
+          <a:chOff x="0" y="0"/>
+          <a:chExt cx="0" cy="0"/>
+        </a:xfrm>
+      </p:grpSpPr>
       <p:sp>
         <p:nvSpPr>
           <p:cNvPr id="2" name="Rectangle 1"/>
@@ -5160,6 +6211,7 @@
           <a:lstStyle/>
           <a:p>
             <a:pPr algn="ctr"/>
+            <a:endParaRPr/>
           </a:p>
         </p:txBody>
       </p:sp>
@@ -5327,7 +6379,7 @@
 </file>
 
 <file path=ppt/slides/slide6.xml><?xml version="1.0" encoding="utf-8"?>
-<p:sld xmlns:a="http://schemas.openxmlformats.org/drawingml/2006/main" xmlns:p="http://schemas.openxmlformats.org/presentationml/2006/main" xmlns:r="http://schemas.openxmlformats.org/officeDocument/2006/relationships">
+<p:sld xmlns:a="http://schemas.openxmlformats.org/drawingml/2006/main" xmlns:r="http://schemas.openxmlformats.org/officeDocument/2006/relationships" xmlns:p="http://schemas.openxmlformats.org/presentationml/2006/main">
   <p:cSld>
     <p:spTree>
       <p:nvGrpSpPr>
@@ -5335,7 +6387,14 @@
         <p:cNvGrpSpPr/>
         <p:nvPr/>
       </p:nvGrpSpPr>
-      <p:grpSpPr/>
+      <p:grpSpPr>
+        <a:xfrm>
+          <a:off x="0" y="0"/>
+          <a:ext cx="0" cy="0"/>
+          <a:chOff x="0" y="0"/>
+          <a:chExt cx="0" cy="0"/>
+        </a:xfrm>
+      </p:grpSpPr>
       <p:sp>
         <p:nvSpPr>
           <p:cNvPr id="2" name="Rectangle 1"/>
@@ -5376,6 +6435,7 @@
           <a:lstStyle/>
           <a:p>
             <a:pPr algn="ctr"/>
+            <a:endParaRPr/>
           </a:p>
         </p:txBody>
       </p:sp>
@@ -5432,7 +6492,7 @@
         </p:nvGraphicFramePr>
         <p:xfrm>
           <a:off x="548640" y="1645920"/>
-          <a:ext cx="6400800" cy="1920240"/>
+          <a:ext cx="6400800" cy="2188464"/>
         </p:xfrm>
         <a:graphic>
           <a:graphicData uri="http://schemas.openxmlformats.org/drawingml/2006/table">
@@ -5441,12 +6501,48 @@
                 <a:tableStyleId>{5C22544A-7EE6-4342-B048-85BDC9FD1C3A}</a:tableStyleId>
               </a:tblPr>
               <a:tblGrid>
-                <a:gridCol w="1066800"/>
-                <a:gridCol w="1066800"/>
-                <a:gridCol w="1066800"/>
-                <a:gridCol w="1066800"/>
-                <a:gridCol w="1066800"/>
-                <a:gridCol w="1066800"/>
+                <a:gridCol w="1066800">
+                  <a:extLst>
+                    <a:ext uri="{9D8B030D-6E8A-4147-A177-3AD203B41FA5}">
+                      <a16:colId xmlns:a16="http://schemas.microsoft.com/office/drawing/2014/main" val="20000"/>
+                    </a:ext>
+                  </a:extLst>
+                </a:gridCol>
+                <a:gridCol w="1066800">
+                  <a:extLst>
+                    <a:ext uri="{9D8B030D-6E8A-4147-A177-3AD203B41FA5}">
+                      <a16:colId xmlns:a16="http://schemas.microsoft.com/office/drawing/2014/main" val="20001"/>
+                    </a:ext>
+                  </a:extLst>
+                </a:gridCol>
+                <a:gridCol w="1066800">
+                  <a:extLst>
+                    <a:ext uri="{9D8B030D-6E8A-4147-A177-3AD203B41FA5}">
+                      <a16:colId xmlns:a16="http://schemas.microsoft.com/office/drawing/2014/main" val="20002"/>
+                    </a:ext>
+                  </a:extLst>
+                </a:gridCol>
+                <a:gridCol w="1066800">
+                  <a:extLst>
+                    <a:ext uri="{9D8B030D-6E8A-4147-A177-3AD203B41FA5}">
+                      <a16:colId xmlns:a16="http://schemas.microsoft.com/office/drawing/2014/main" val="20003"/>
+                    </a:ext>
+                  </a:extLst>
+                </a:gridCol>
+                <a:gridCol w="1066800">
+                  <a:extLst>
+                    <a:ext uri="{9D8B030D-6E8A-4147-A177-3AD203B41FA5}">
+                      <a16:colId xmlns:a16="http://schemas.microsoft.com/office/drawing/2014/main" val="20004"/>
+                    </a:ext>
+                  </a:extLst>
+                </a:gridCol>
+                <a:gridCol w="1066800">
+                  <a:extLst>
+                    <a:ext uri="{9D8B030D-6E8A-4147-A177-3AD203B41FA5}">
+                      <a16:colId xmlns:a16="http://schemas.microsoft.com/office/drawing/2014/main" val="20005"/>
+                    </a:ext>
+                  </a:extLst>
+                </a:gridCol>
               </a:tblGrid>
               <a:tr h="384048">
                 <a:tc>
@@ -5527,6 +6623,11 @@
                   </a:txBody>
                   <a:tcPr/>
                 </a:tc>
+                <a:extLst>
+                  <a:ext uri="{0D108BD9-81ED-4DB2-BD59-A6C34878D82A}">
+                    <a16:rowId xmlns:a16="http://schemas.microsoft.com/office/drawing/2014/main" val="10000"/>
+                  </a:ext>
+                </a:extLst>
               </a:tr>
               <a:tr h="384048">
                 <a:tc>
@@ -5607,6 +6708,11 @@
                   </a:txBody>
                   <a:tcPr/>
                 </a:tc>
+                <a:extLst>
+                  <a:ext uri="{0D108BD9-81ED-4DB2-BD59-A6C34878D82A}">
+                    <a16:rowId xmlns:a16="http://schemas.microsoft.com/office/drawing/2014/main" val="10001"/>
+                  </a:ext>
+                </a:extLst>
               </a:tr>
               <a:tr h="384048">
                 <a:tc>
@@ -5687,6 +6793,11 @@
                   </a:txBody>
                   <a:tcPr/>
                 </a:tc>
+                <a:extLst>
+                  <a:ext uri="{0D108BD9-81ED-4DB2-BD59-A6C34878D82A}">
+                    <a16:rowId xmlns:a16="http://schemas.microsoft.com/office/drawing/2014/main" val="10002"/>
+                  </a:ext>
+                </a:extLst>
               </a:tr>
               <a:tr h="384048">
                 <a:tc>
@@ -5767,6 +6878,11 @@
                   </a:txBody>
                   <a:tcPr/>
                 </a:tc>
+                <a:extLst>
+                  <a:ext uri="{0D108BD9-81ED-4DB2-BD59-A6C34878D82A}">
+                    <a16:rowId xmlns:a16="http://schemas.microsoft.com/office/drawing/2014/main" val="10003"/>
+                  </a:ext>
+                </a:extLst>
               </a:tr>
               <a:tr h="384048">
                 <a:tc>
@@ -5847,6 +6963,11 @@
                   </a:txBody>
                   <a:tcPr/>
                 </a:tc>
+                <a:extLst>
+                  <a:ext uri="{0D108BD9-81ED-4DB2-BD59-A6C34878D82A}">
+                    <a16:rowId xmlns:a16="http://schemas.microsoft.com/office/drawing/2014/main" val="10004"/>
+                  </a:ext>
+                </a:extLst>
               </a:tr>
             </a:tbl>
           </a:graphicData>
@@ -5918,7 +7039,7 @@
 </file>
 
 <file path=ppt/slides/slide7.xml><?xml version="1.0" encoding="utf-8"?>
-<p:sld xmlns:a="http://schemas.openxmlformats.org/drawingml/2006/main" xmlns:p="http://schemas.openxmlformats.org/presentationml/2006/main" xmlns:r="http://schemas.openxmlformats.org/officeDocument/2006/relationships">
+<p:sld xmlns:a="http://schemas.openxmlformats.org/drawingml/2006/main" xmlns:r="http://schemas.openxmlformats.org/officeDocument/2006/relationships" xmlns:p="http://schemas.openxmlformats.org/presentationml/2006/main">
   <p:cSld>
     <p:spTree>
       <p:nvGrpSpPr>
@@ -5926,7 +7047,14 @@
         <p:cNvGrpSpPr/>
         <p:nvPr/>
       </p:nvGrpSpPr>
-      <p:grpSpPr/>
+      <p:grpSpPr>
+        <a:xfrm>
+          <a:off x="0" y="0"/>
+          <a:ext cx="0" cy="0"/>
+          <a:chOff x="0" y="0"/>
+          <a:chExt cx="0" cy="0"/>
+        </a:xfrm>
+      </p:grpSpPr>
       <p:sp>
         <p:nvSpPr>
           <p:cNvPr id="2" name="Rectangle 1"/>
@@ -5967,6 +7095,7 @@
           <a:lstStyle/>
           <a:p>
             <a:pPr algn="ctr"/>
+            <a:endParaRPr/>
           </a:p>
         </p:txBody>
       </p:sp>
@@ -6046,7 +7175,7 @@
 </file>
 
 <file path=ppt/slides/slide8.xml><?xml version="1.0" encoding="utf-8"?>
-<p:sld xmlns:a="http://schemas.openxmlformats.org/drawingml/2006/main" xmlns:p="http://schemas.openxmlformats.org/presentationml/2006/main" xmlns:r="http://schemas.openxmlformats.org/officeDocument/2006/relationships">
+<p:sld xmlns:a="http://schemas.openxmlformats.org/drawingml/2006/main" xmlns:r="http://schemas.openxmlformats.org/officeDocument/2006/relationships" xmlns:p="http://schemas.openxmlformats.org/presentationml/2006/main">
   <p:cSld>
     <p:spTree>
       <p:nvGrpSpPr>
@@ -6054,7 +7183,14 @@
         <p:cNvGrpSpPr/>
         <p:nvPr/>
       </p:nvGrpSpPr>
-      <p:grpSpPr/>
+      <p:grpSpPr>
+        <a:xfrm>
+          <a:off x="0" y="0"/>
+          <a:ext cx="0" cy="0"/>
+          <a:chOff x="0" y="0"/>
+          <a:chExt cx="0" cy="0"/>
+        </a:xfrm>
+      </p:grpSpPr>
       <p:sp>
         <p:nvSpPr>
           <p:cNvPr id="2" name="Rectangle 1"/>
@@ -6095,6 +7231,7 @@
           <a:lstStyle/>
           <a:p>
             <a:pPr algn="ctr"/>
+            <a:endParaRPr/>
           </a:p>
         </p:txBody>
       </p:sp>
@@ -6151,7 +7288,7 @@
         </p:nvGraphicFramePr>
         <p:xfrm>
           <a:off x="457200" y="1554480"/>
-          <a:ext cx="7498079" cy="2304288"/>
+          <a:ext cx="7498079" cy="2822448"/>
         </p:xfrm>
         <a:graphic>
           <a:graphicData uri="http://schemas.openxmlformats.org/drawingml/2006/table">
@@ -6160,10 +7297,34 @@
                 <a:tableStyleId>{5C22544A-7EE6-4342-B048-85BDC9FD1C3A}</a:tableStyleId>
               </a:tblPr>
               <a:tblGrid>
-                <a:gridCol w="1874519"/>
-                <a:gridCol w="1874519"/>
-                <a:gridCol w="1874519"/>
-                <a:gridCol w="1874522"/>
+                <a:gridCol w="1874519">
+                  <a:extLst>
+                    <a:ext uri="{9D8B030D-6E8A-4147-A177-3AD203B41FA5}">
+                      <a16:colId xmlns:a16="http://schemas.microsoft.com/office/drawing/2014/main" val="20000"/>
+                    </a:ext>
+                  </a:extLst>
+                </a:gridCol>
+                <a:gridCol w="1874519">
+                  <a:extLst>
+                    <a:ext uri="{9D8B030D-6E8A-4147-A177-3AD203B41FA5}">
+                      <a16:colId xmlns:a16="http://schemas.microsoft.com/office/drawing/2014/main" val="20001"/>
+                    </a:ext>
+                  </a:extLst>
+                </a:gridCol>
+                <a:gridCol w="1874519">
+                  <a:extLst>
+                    <a:ext uri="{9D8B030D-6E8A-4147-A177-3AD203B41FA5}">
+                      <a16:colId xmlns:a16="http://schemas.microsoft.com/office/drawing/2014/main" val="20002"/>
+                    </a:ext>
+                  </a:extLst>
+                </a:gridCol>
+                <a:gridCol w="1874522">
+                  <a:extLst>
+                    <a:ext uri="{9D8B030D-6E8A-4147-A177-3AD203B41FA5}">
+                      <a16:colId xmlns:a16="http://schemas.microsoft.com/office/drawing/2014/main" val="20003"/>
+                    </a:ext>
+                  </a:extLst>
+                </a:gridCol>
               </a:tblGrid>
               <a:tr h="384048">
                 <a:tc>
@@ -6218,6 +7379,11 @@
                   </a:txBody>
                   <a:tcPr/>
                 </a:tc>
+                <a:extLst>
+                  <a:ext uri="{0D108BD9-81ED-4DB2-BD59-A6C34878D82A}">
+                    <a16:rowId xmlns:a16="http://schemas.microsoft.com/office/drawing/2014/main" val="10000"/>
+                  </a:ext>
+                </a:extLst>
               </a:tr>
               <a:tr h="384048">
                 <a:tc>
@@ -6272,6 +7438,11 @@
                   </a:txBody>
                   <a:tcPr/>
                 </a:tc>
+                <a:extLst>
+                  <a:ext uri="{0D108BD9-81ED-4DB2-BD59-A6C34878D82A}">
+                    <a16:rowId xmlns:a16="http://schemas.microsoft.com/office/drawing/2014/main" val="10001"/>
+                  </a:ext>
+                </a:extLst>
               </a:tr>
               <a:tr h="384048">
                 <a:tc>
@@ -6326,6 +7497,11 @@
                   </a:txBody>
                   <a:tcPr/>
                 </a:tc>
+                <a:extLst>
+                  <a:ext uri="{0D108BD9-81ED-4DB2-BD59-A6C34878D82A}">
+                    <a16:rowId xmlns:a16="http://schemas.microsoft.com/office/drawing/2014/main" val="10002"/>
+                  </a:ext>
+                </a:extLst>
               </a:tr>
               <a:tr h="384048">
                 <a:tc>
@@ -6380,6 +7556,11 @@
                   </a:txBody>
                   <a:tcPr/>
                 </a:tc>
+                <a:extLst>
+                  <a:ext uri="{0D108BD9-81ED-4DB2-BD59-A6C34878D82A}">
+                    <a16:rowId xmlns:a16="http://schemas.microsoft.com/office/drawing/2014/main" val="10003"/>
+                  </a:ext>
+                </a:extLst>
               </a:tr>
               <a:tr h="384048">
                 <a:tc>
@@ -6434,6 +7615,11 @@
                   </a:txBody>
                   <a:tcPr/>
                 </a:tc>
+                <a:extLst>
+                  <a:ext uri="{0D108BD9-81ED-4DB2-BD59-A6C34878D82A}">
+                    <a16:rowId xmlns:a16="http://schemas.microsoft.com/office/drawing/2014/main" val="10004"/>
+                  </a:ext>
+                </a:extLst>
               </a:tr>
               <a:tr h="384048">
                 <a:tc>
@@ -6488,6 +7674,11 @@
                   </a:txBody>
                   <a:tcPr/>
                 </a:tc>
+                <a:extLst>
+                  <a:ext uri="{0D108BD9-81ED-4DB2-BD59-A6C34878D82A}">
+                    <a16:rowId xmlns:a16="http://schemas.microsoft.com/office/drawing/2014/main" val="10005"/>
+                  </a:ext>
+                </a:extLst>
               </a:tr>
             </a:tbl>
           </a:graphicData>
@@ -6526,7 +7717,7 @@
 </file>
 
 <file path=ppt/slides/slide9.xml><?xml version="1.0" encoding="utf-8"?>
-<p:sld xmlns:a="http://schemas.openxmlformats.org/drawingml/2006/main" xmlns:p="http://schemas.openxmlformats.org/presentationml/2006/main" xmlns:r="http://schemas.openxmlformats.org/officeDocument/2006/relationships">
+<p:sld xmlns:a="http://schemas.openxmlformats.org/drawingml/2006/main" xmlns:r="http://schemas.openxmlformats.org/officeDocument/2006/relationships" xmlns:p="http://schemas.openxmlformats.org/presentationml/2006/main">
   <p:cSld>
     <p:spTree>
       <p:nvGrpSpPr>
@@ -6534,7 +7725,14 @@
         <p:cNvGrpSpPr/>
         <p:nvPr/>
       </p:nvGrpSpPr>
-      <p:grpSpPr/>
+      <p:grpSpPr>
+        <a:xfrm>
+          <a:off x="0" y="0"/>
+          <a:ext cx="0" cy="0"/>
+          <a:chOff x="0" y="0"/>
+          <a:chExt cx="0" cy="0"/>
+        </a:xfrm>
+      </p:grpSpPr>
       <p:sp>
         <p:nvSpPr>
           <p:cNvPr id="2" name="Rectangle 1"/>
@@ -6575,6 +7773,7 @@
           <a:lstStyle/>
           <a:p>
             <a:pPr algn="ctr"/>
+            <a:endParaRPr/>
           </a:p>
         </p:txBody>
       </p:sp>

</xml_diff>

<commit_message>
docs: report single-annotator agreement, fill cover and synthetic review
Report text now matches what was actually done (1 human blind annotator vs GPT); slide 1 metrics come from results.json.
</commit_message>
<xml_diff>
--- a/reports/Slide_BaoCao_DoAn.pptx
+++ b/reports/Slide_BaoCao_DoAn.pptx
@@ -3529,7 +3529,7 @@
                   <a:srgbClr val="1A202C"/>
                 </a:solidFill>
               </a:rPr>
-              <a:t>•  Mô hình tối ưu: TF-IDF (1,2)-gram + LinearSVC (Test F1: 90.5%, Thật F1: 62.0%)</a:t>
+              <a:t>•  Mô hình chọn theo val: TF-IDF (1,2)-gram + LinearSVC (Test F1: 90.5%, Thật F1: 62.0%)</a:t>
             </a:r>
           </a:p>
           <a:p>
@@ -5369,7 +5369,7 @@
                   <a:srgbClr val="1A202C"/>
                 </a:solidFill>
               </a:rPr>
-              <a:t>• Test thật: 42 câu của người dân trên chinhsachonline.chinhphu.vn, nhãn LLM gán theo Điều mà Bộ trả lời viện dẫn</a:t>
+              <a:t>• Test thật: 42 câu của người dân trên chinhsachonline.chinhphu.vn, nhãn LLM gán theo Điều mà Bộ trả lời viện dẫn, 1 thành viên gán nhãn mù kiểm chứng</a:t>
             </a:r>
           </a:p>
         </p:txBody>

</xml_diff>

<commit_message>
style(slides): center the closing thank-you slide
</commit_message>
<xml_diff>
--- a/reports/Slide_BaoCao_DoAn.pptx
+++ b/reports/Slide_BaoCao_DoAn.pptx
@@ -4327,8 +4327,8 @@
         </p:nvSpPr>
         <p:spPr>
           <a:xfrm>
-            <a:off x="548640" y="320040"/>
-            <a:ext cx="10972800" cy="822960"/>
+            <a:off x="0" y="0"/>
+            <a:ext cx="12191695" cy="6858000"/>
           </a:xfrm>
           <a:prstGeom prst="rect">
             <a:avLst/>
@@ -4336,13 +4336,14 @@
           <a:noFill/>
         </p:spPr>
         <p:txBody>
-          <a:bodyPr wrap="none">
+          <a:bodyPr wrap="square" anchor="ctr">
             <a:spAutoFit/>
           </a:bodyPr>
           <a:lstStyle/>
           <a:p>
-            <a:r>
-              <a:rPr sz="3000" b="1">
+            <a:pPr algn="ctr"/>
+            <a:r>
+              <a:rPr sz="3600" b="1">
                 <a:solidFill>
                   <a:srgbClr val="1A365D"/>
                 </a:solidFill>
@@ -4351,8 +4352,13 @@
             </a:r>
           </a:p>
           <a:p>
-            <a:r>
-              <a:rPr sz="1500">
+            <a:pPr algn="ctr">
+              <a:spcBef>
+                <a:spcPts val="1200"/>
+              </a:spcBef>
+            </a:pPr>
+            <a:r>
+              <a:rPr sz="2200" b="0">
                 <a:solidFill>
                   <a:srgbClr val="4A5568"/>
                 </a:solidFill>

</xml_diff>

<commit_message>
docs: add demo screenshot to report 7.4 and a demo slide
Replaces the last report placeholder; both builders pick up reports/figures/demo.png so rebuilds keep the image.
</commit_message>
<xml_diff>
--- a/reports/Slide_BaoCao_DoAn.pptx
+++ b/reports/Slide_BaoCao_DoAn.pptx
@@ -17,6 +17,7 @@
     <p:sldId id="265" r:id="rId16"/>
     <p:sldId id="266" r:id="rId17"/>
     <p:sldId id="267" r:id="rId18"/>
+    <p:sldId id="268" r:id="rId19"/>
   </p:sldIdLst>
   <p:sldSz cx="12191695" cy="6858000" type="screen4x3"/>
   <p:notesSz cx="6858000" cy="9144000"/>
@@ -4170,6 +4171,134 @@
                   <a:srgbClr val="1A365D"/>
                 </a:solidFill>
               </a:rPr>
+              <a:t>Demo giao diện</a:t>
+            </a:r>
+          </a:p>
+          <a:p>
+            <a:r>
+              <a:rPr sz="1500">
+                <a:solidFill>
+                  <a:srgbClr val="4A5568"/>
+                </a:solidFill>
+              </a:rPr>
+              <a:t>streamlit run app.py · câu hỏi → nhóm quy định → Điều luật liên quan</a:t>
+            </a:r>
+          </a:p>
+        </p:txBody>
+      </p:sp>
+      <p:pic>
+        <p:nvPicPr>
+          <p:cNvPr id="4" name="Picture 3" descr="demo.png"/>
+          <p:cNvPicPr>
+            <a:picLocks noChangeAspect="1"/>
+          </p:cNvPicPr>
+          <p:nvPr/>
+        </p:nvPicPr>
+        <p:blipFill>
+          <a:blip r:embed="rId2"/>
+          <a:stretch>
+            <a:fillRect/>
+          </a:stretch>
+        </p:blipFill>
+        <p:spPr>
+          <a:xfrm>
+            <a:off x="1257719" y="1417320"/>
+            <a:ext cx="9676256" cy="5212080"/>
+          </a:xfrm>
+          <a:prstGeom prst="rect">
+            <a:avLst/>
+          </a:prstGeom>
+        </p:spPr>
+      </p:pic>
+    </p:spTree>
+  </p:cSld>
+  <p:clrMapOvr>
+    <a:masterClrMapping/>
+  </p:clrMapOvr>
+</p:sld>
+</file>
+
+<file path=ppt/slides/slide12.xml><?xml version="1.0" encoding="utf-8"?>
+<p:sld xmlns:a="http://schemas.openxmlformats.org/drawingml/2006/main" xmlns:p="http://schemas.openxmlformats.org/presentationml/2006/main" xmlns:r="http://schemas.openxmlformats.org/officeDocument/2006/relationships">
+  <p:cSld>
+    <p:spTree>
+      <p:nvGrpSpPr>
+        <p:cNvPr id="1" name=""/>
+        <p:cNvGrpSpPr/>
+        <p:nvPr/>
+      </p:nvGrpSpPr>
+      <p:grpSpPr/>
+      <p:sp>
+        <p:nvSpPr>
+          <p:cNvPr id="2" name="Rectangle 1"/>
+          <p:cNvSpPr/>
+          <p:nvPr/>
+        </p:nvSpPr>
+        <p:spPr>
+          <a:xfrm>
+            <a:off x="0" y="0"/>
+            <a:ext cx="12191695" cy="109728"/>
+          </a:xfrm>
+          <a:prstGeom prst="rect">
+            <a:avLst/>
+          </a:prstGeom>
+          <a:solidFill>
+            <a:srgbClr val="DD6B20"/>
+          </a:solidFill>
+          <a:ln>
+            <a:noFill/>
+          </a:ln>
+        </p:spPr>
+        <p:style>
+          <a:lnRef idx="1">
+            <a:schemeClr val="accent1"/>
+          </a:lnRef>
+          <a:fillRef idx="3">
+            <a:schemeClr val="accent1"/>
+          </a:fillRef>
+          <a:effectRef idx="2">
+            <a:schemeClr val="accent1"/>
+          </a:effectRef>
+          <a:fontRef idx="minor">
+            <a:schemeClr val="lt1"/>
+          </a:fontRef>
+        </p:style>
+        <p:txBody>
+          <a:bodyPr rtlCol="0" anchor="ctr"/>
+          <a:lstStyle/>
+          <a:p>
+            <a:pPr algn="ctr"/>
+          </a:p>
+        </p:txBody>
+      </p:sp>
+      <p:sp>
+        <p:nvSpPr>
+          <p:cNvPr id="3" name="TextBox 2"/>
+          <p:cNvSpPr txBox="1"/>
+          <p:nvPr/>
+        </p:nvSpPr>
+        <p:spPr>
+          <a:xfrm>
+            <a:off x="548640" y="320040"/>
+            <a:ext cx="10972800" cy="822960"/>
+          </a:xfrm>
+          <a:prstGeom prst="rect">
+            <a:avLst/>
+          </a:prstGeom>
+          <a:noFill/>
+        </p:spPr>
+        <p:txBody>
+          <a:bodyPr wrap="none">
+            <a:spAutoFit/>
+          </a:bodyPr>
+          <a:lstStyle/>
+          <a:p>
+            <a:r>
+              <a:rPr sz="3000" b="1">
+                <a:solidFill>
+                  <a:srgbClr val="1A365D"/>
+                </a:solidFill>
+              </a:rPr>
               <a:t>Kết luận &amp; hướng phát triển</a:t>
             </a:r>
           </a:p>
@@ -4266,7 +4395,7 @@
 </p:sld>
 </file>
 
-<file path=ppt/slides/slide12.xml><?xml version="1.0" encoding="utf-8"?>
+<file path=ppt/slides/slide13.xml><?xml version="1.0" encoding="utf-8"?>
 <p:sld xmlns:a="http://schemas.openxmlformats.org/drawingml/2006/main" xmlns:p="http://schemas.openxmlformats.org/presentationml/2006/main" xmlns:r="http://schemas.openxmlformats.org/officeDocument/2006/relationships">
   <p:cSld>
     <p:spTree>

</xml_diff>